<commit_message>
dittvin PPTX: cast table EMU offsets to int so Google Slides converter accepts them (float EMU caused import failure)
</commit_message>
<xml_diff>
--- a/dittvin-cro-audit/dittvin-ecomhouse-pitch-DA.pptx
+++ b/dittvin-cro-audit/dittvin-ecomhouse-pitch-DA.pptx
@@ -4361,7 +4361,7 @@
           <p:nvPr/>
         </p:nvGraphicFramePr>
         <p:xfrm>
-          <a:off x="883767.5" y="2103120"/>
+          <a:off x="883767" y="2103120"/>
           <a:ext cx="10424156" cy="1463040"/>
         </p:xfrm>
         <a:graphic>
@@ -5223,7 +5223,7 @@
           <p:nvPr/>
         </p:nvGraphicFramePr>
         <p:xfrm>
-          <a:off x="883767.5" y="2596896"/>
+          <a:off x="883767" y="2596896"/>
           <a:ext cx="10424158" cy="2194560"/>
         </p:xfrm>
         <a:graphic>
@@ -7761,7 +7761,7 @@
           <p:nvPr/>
         </p:nvGraphicFramePr>
         <p:xfrm>
-          <a:off x="883767.5" y="4233672"/>
+          <a:off x="883767" y="4233672"/>
           <a:ext cx="10424158" cy="1682496"/>
         </p:xfrm>
         <a:graphic>
@@ -8508,7 +8508,7 @@
           <p:nvPr/>
         </p:nvGraphicFramePr>
         <p:xfrm>
-          <a:off x="883767.5" y="2596896"/>
+          <a:off x="883767" y="2596896"/>
           <a:ext cx="10424156" cy="1828800"/>
         </p:xfrm>
         <a:graphic>
@@ -9452,7 +9452,7 @@
           <p:nvPr/>
         </p:nvGraphicFramePr>
         <p:xfrm>
-          <a:off x="883767.5" y="2103120"/>
+          <a:off x="883767" y="2103120"/>
           <a:ext cx="10424158" cy="1828800"/>
         </p:xfrm>
         <a:graphic>
@@ -10315,7 +10315,7 @@
           <p:nvPr/>
         </p:nvGraphicFramePr>
         <p:xfrm>
-          <a:off x="883767.5" y="2377440"/>
+          <a:off x="883767" y="2377440"/>
           <a:ext cx="10424158" cy="2670048"/>
         </p:xfrm>
         <a:graphic>
@@ -33159,7 +33159,7 @@
           <p:nvPr/>
         </p:nvGraphicFramePr>
         <p:xfrm>
-          <a:off x="883767.5" y="2377440"/>
+          <a:off x="883767" y="2377440"/>
           <a:ext cx="10424158" cy="2194560"/>
         </p:xfrm>
         <a:graphic>
@@ -36253,7 +36253,7 @@
           <p:nvPr/>
         </p:nvGraphicFramePr>
         <p:xfrm>
-          <a:off x="883767.5" y="2377440"/>
+          <a:off x="883767" y="2377440"/>
           <a:ext cx="10424156" cy="1828800"/>
         </p:xfrm>
         <a:graphic>
@@ -37197,7 +37197,7 @@
           <p:nvPr/>
         </p:nvGraphicFramePr>
         <p:xfrm>
-          <a:off x="883767.5" y="2103120"/>
+          <a:off x="883767" y="2103120"/>
           <a:ext cx="10424158" cy="2560320"/>
         </p:xfrm>
         <a:graphic>
@@ -40050,7 +40050,7 @@
           <p:nvPr/>
         </p:nvGraphicFramePr>
         <p:xfrm>
-          <a:off x="883767.5" y="3922776"/>
+          <a:off x="883767" y="3922776"/>
           <a:ext cx="10424158" cy="1353312"/>
         </p:xfrm>
         <a:graphic>
@@ -46992,7 +46992,7 @@
           <p:nvPr/>
         </p:nvGraphicFramePr>
         <p:xfrm>
-          <a:off x="883767.5" y="2596896"/>
+          <a:off x="883767" y="2596896"/>
           <a:ext cx="10424158" cy="2999232"/>
         </p:xfrm>
         <a:graphic>

</xml_diff>

<commit_message>
dittvin: add Recommended Tests (T1/T2/T3 with hi-fi mockups) + Working With EcomHouse (how we work, performance fee) sections; regenerate EN/DA PPTX (57 slides)
</commit_message>
<xml_diff>
--- a/dittvin-cro-audit/dittvin-ecomhouse-pitch-DA.pptx
+++ b/dittvin-cro-audit/dittvin-ecomhouse-pitch-DA.pptx
@@ -55,6 +55,13 @@
     <p:sldId id="303" r:id="rId54"/>
     <p:sldId id="304" r:id="rId55"/>
     <p:sldId id="305" r:id="rId56"/>
+    <p:sldId id="306" r:id="rId57"/>
+    <p:sldId id="307" r:id="rId58"/>
+    <p:sldId id="308" r:id="rId59"/>
+    <p:sldId id="309" r:id="rId60"/>
+    <p:sldId id="310" r:id="rId61"/>
+    <p:sldId id="311" r:id="rId62"/>
+    <p:sldId id="312" r:id="rId63"/>
   </p:sldIdLst>
   <p:sldSz cx="12191695" cy="6858000" type="screen4x3"/>
   <p:notesSz cx="6858000" cy="9144000"/>
@@ -45462,6 +45469,4104 @@
       </p:sp>
       <p:sp>
         <p:nvSpPr>
+          <p:cNvPr id="7" name="TextBox 6"/>
+          <p:cNvSpPr txBox="1"/>
+          <p:nvPr/>
+        </p:nvSpPr>
+        <p:spPr>
+          <a:xfrm>
+            <a:off x="0" y="1828800"/>
+            <a:ext cx="12191695" cy="1828800"/>
+          </a:xfrm>
+          <a:prstGeom prst="rect">
+            <a:avLst/>
+          </a:prstGeom>
+          <a:noFill/>
+        </p:spPr>
+        <p:txBody>
+          <a:bodyPr wrap="square" lIns="0" rIns="0" tIns="0" bIns="0" anchor="ctr">
+            <a:spAutoFit/>
+          </a:bodyPr>
+          <a:lstStyle/>
+          <a:p>
+            <a:pPr algn="ctr"/>
+            <a:r>
+              <a:rPr sz="11000" b="0" i="0">
+                <a:solidFill>
+                  <a:srgbClr val="332A02"/>
+                </a:solidFill>
+                <a:latin typeface="Menlo"/>
+              </a:rPr>
+              <a:t>09</a:t>
+            </a:r>
+          </a:p>
+        </p:txBody>
+      </p:sp>
+      <p:sp>
+        <p:nvSpPr>
+          <p:cNvPr id="8" name="TextBox 7"/>
+          <p:cNvSpPr txBox="1"/>
+          <p:nvPr/>
+        </p:nvSpPr>
+        <p:spPr>
+          <a:xfrm>
+            <a:off x="0" y="3291840"/>
+            <a:ext cx="12191695" cy="274320"/>
+          </a:xfrm>
+          <a:prstGeom prst="rect">
+            <a:avLst/>
+          </a:prstGeom>
+          <a:noFill/>
+        </p:spPr>
+        <p:txBody>
+          <a:bodyPr wrap="square" lIns="0" rIns="0" tIns="0" bIns="0" anchor="t">
+            <a:spAutoFit/>
+          </a:bodyPr>
+          <a:lstStyle/>
+          <a:p>
+            <a:pPr algn="ctr"/>
+            <a:r>
+              <a:rPr sz="1100" b="1" i="0" spc="400">
+                <a:solidFill>
+                  <a:srgbClr val="F7D007"/>
+                </a:solidFill>
+                <a:latin typeface="Helvetica Neue"/>
+              </a:rPr>
+              <a:t/>
+            </a:r>
+          </a:p>
+        </p:txBody>
+      </p:sp>
+      <p:sp>
+        <p:nvSpPr>
+          <p:cNvPr id="9" name="TextBox 8"/>
+          <p:cNvSpPr txBox="1"/>
+          <p:nvPr/>
+        </p:nvSpPr>
+        <p:spPr>
+          <a:xfrm>
+            <a:off x="731520" y="3611880"/>
+            <a:ext cx="10728655" cy="822960"/>
+          </a:xfrm>
+          <a:prstGeom prst="rect">
+            <a:avLst/>
+          </a:prstGeom>
+          <a:noFill/>
+        </p:spPr>
+        <p:txBody>
+          <a:bodyPr wrap="square" lIns="0" rIns="0" tIns="0" bIns="0" anchor="t">
+            <a:spAutoFit/>
+          </a:bodyPr>
+          <a:lstStyle/>
+          <a:p>
+            <a:pPr algn="ctr"/>
+            <a:r>
+              <a:rPr sz="4400" b="1" i="0" spc="-100">
+                <a:solidFill>
+                  <a:srgbClr val="FFFFFF"/>
+                </a:solidFill>
+                <a:latin typeface="Helvetica Neue"/>
+              </a:rPr>
+              <a:t>Anbefalede tests</a:t>
+            </a:r>
+          </a:p>
+        </p:txBody>
+      </p:sp>
+      <p:sp>
+        <p:nvSpPr>
+          <p:cNvPr id="10" name="TextBox 9"/>
+          <p:cNvSpPr txBox="1"/>
+          <p:nvPr/>
+        </p:nvSpPr>
+        <p:spPr>
+          <a:xfrm>
+            <a:off x="2103120" y="4480560"/>
+            <a:ext cx="7985455" cy="1097280"/>
+          </a:xfrm>
+          <a:prstGeom prst="rect">
+            <a:avLst/>
+          </a:prstGeom>
+          <a:noFill/>
+        </p:spPr>
+        <p:txBody>
+          <a:bodyPr wrap="square" lIns="0" rIns="0" tIns="0" bIns="0" anchor="t">
+            <a:spAutoFit/>
+          </a:bodyPr>
+          <a:lstStyle/>
+          <a:p>
+            <a:pPr algn="ctr"/>
+            <a:r>
+              <a:rPr sz="1300" b="0" i="0">
+                <a:solidFill>
+                  <a:srgbClr val="999999"/>
+                </a:solidFill>
+                <a:latin typeface="Helvetica Neue"/>
+              </a:rPr>
+              <a:t>De tre tests med størst løftestang at køre først, hver især vist som mockup på den rigtige side.</a:t>
+            </a:r>
+          </a:p>
+        </p:txBody>
+      </p:sp>
+    </p:spTree>
+  </p:cSld>
+  <p:clrMapOvr>
+    <a:masterClrMapping/>
+  </p:clrMapOvr>
+</p:sld>
+</file>
+
+<file path=ppt/slides/slide51.xml><?xml version="1.0" encoding="utf-8"?>
+<p:sld xmlns:a="http://schemas.openxmlformats.org/drawingml/2006/main" xmlns:p="http://schemas.openxmlformats.org/presentationml/2006/main" xmlns:r="http://schemas.openxmlformats.org/officeDocument/2006/relationships">
+  <p:cSld>
+    <p:spTree>
+      <p:nvGrpSpPr>
+        <p:cNvPr id="1" name=""/>
+        <p:cNvGrpSpPr/>
+        <p:nvPr/>
+      </p:nvGrpSpPr>
+      <p:grpSpPr/>
+      <p:sp>
+        <p:nvSpPr>
+          <p:cNvPr id="2" name="Rectangle 1"/>
+          <p:cNvSpPr/>
+          <p:nvPr/>
+        </p:nvSpPr>
+        <p:spPr>
+          <a:xfrm>
+            <a:off x="0" y="0"/>
+            <a:ext cx="12191695" cy="6858000"/>
+          </a:xfrm>
+          <a:prstGeom prst="rect">
+            <a:avLst/>
+          </a:prstGeom>
+          <a:solidFill>
+            <a:srgbClr val="000000"/>
+          </a:solidFill>
+          <a:ln>
+            <a:noFill/>
+          </a:ln>
+        </p:spPr>
+        <p:style>
+          <a:lnRef idx="1">
+            <a:schemeClr val="accent1"/>
+          </a:lnRef>
+          <a:fillRef idx="3">
+            <a:schemeClr val="accent1"/>
+          </a:fillRef>
+          <a:effectRef idx="2">
+            <a:schemeClr val="accent1"/>
+          </a:effectRef>
+          <a:fontRef idx="minor">
+            <a:schemeClr val="lt1"/>
+          </a:fontRef>
+        </p:style>
+        <p:txBody>
+          <a:bodyPr rtlCol="0" anchor="ctr"/>
+          <a:lstStyle/>
+          <a:p>
+            <a:pPr algn="ctr"/>
+          </a:p>
+        </p:txBody>
+      </p:sp>
+      <p:pic>
+        <p:nvPicPr>
+          <p:cNvPr id="3" name="Picture 2" descr="ecomhouse-wordmark.png"/>
+          <p:cNvPicPr>
+            <a:picLocks noChangeAspect="1"/>
+          </p:cNvPicPr>
+          <p:nvPr/>
+        </p:nvPicPr>
+        <p:blipFill>
+          <a:blip r:embed="rId2"/>
+          <a:stretch>
+            <a:fillRect/>
+          </a:stretch>
+        </p:blipFill>
+        <p:spPr>
+          <a:xfrm>
+            <a:off x="292608" y="201168"/>
+            <a:ext cx="1873736" cy="201168"/>
+          </a:xfrm>
+          <a:prstGeom prst="rect">
+            <a:avLst/>
+          </a:prstGeom>
+        </p:spPr>
+      </p:pic>
+      <p:sp>
+        <p:nvSpPr>
+          <p:cNvPr id="4" name="TextBox 3"/>
+          <p:cNvSpPr txBox="1"/>
+          <p:nvPr/>
+        </p:nvSpPr>
+        <p:spPr>
+          <a:xfrm>
+            <a:off x="11475720" y="201168"/>
+            <a:ext cx="548640" cy="274320"/>
+          </a:xfrm>
+          <a:prstGeom prst="rect">
+            <a:avLst/>
+          </a:prstGeom>
+          <a:noFill/>
+        </p:spPr>
+        <p:txBody>
+          <a:bodyPr wrap="square" lIns="0" rIns="0" tIns="0" bIns="0" anchor="t">
+            <a:spAutoFit/>
+          </a:bodyPr>
+          <a:lstStyle/>
+          <a:p>
+            <a:pPr algn="r"/>
+            <a:r>
+              <a:rPr sz="1000" b="0" i="0">
+                <a:solidFill>
+                  <a:srgbClr val="EFEEEE"/>
+                </a:solidFill>
+                <a:latin typeface="Helvetica Neue"/>
+              </a:rPr>
+              <a:t>2026</a:t>
+            </a:r>
+          </a:p>
+        </p:txBody>
+      </p:sp>
+      <p:sp>
+        <p:nvSpPr>
+          <p:cNvPr id="5" name="TextBox 4"/>
+          <p:cNvSpPr txBox="1"/>
+          <p:nvPr/>
+        </p:nvSpPr>
+        <p:spPr>
+          <a:xfrm>
+            <a:off x="292608" y="6565392"/>
+            <a:ext cx="4114800" cy="228600"/>
+          </a:xfrm>
+          <a:prstGeom prst="rect">
+            <a:avLst/>
+          </a:prstGeom>
+          <a:noFill/>
+        </p:spPr>
+        <p:txBody>
+          <a:bodyPr wrap="square" lIns="0" rIns="0" tIns="0" bIns="0" anchor="t">
+            <a:spAutoFit/>
+          </a:bodyPr>
+          <a:lstStyle/>
+          <a:p>
+            <a:pPr algn="l"/>
+            <a:r>
+              <a:rPr sz="800" b="0" i="0" spc="150">
+                <a:solidFill>
+                  <a:srgbClr val="EFEEEE"/>
+                </a:solidFill>
+                <a:latin typeface="Helvetica Neue"/>
+              </a:rPr>
+              <a:t>ECOMHOUSE ©ALL RIGHTS RESERVED</a:t>
+            </a:r>
+          </a:p>
+        </p:txBody>
+      </p:sp>
+      <p:sp>
+        <p:nvSpPr>
+          <p:cNvPr id="6" name="TextBox 5"/>
+          <p:cNvSpPr txBox="1"/>
+          <p:nvPr/>
+        </p:nvSpPr>
+        <p:spPr>
+          <a:xfrm>
+            <a:off x="11475720" y="6565392"/>
+            <a:ext cx="548640" cy="228600"/>
+          </a:xfrm>
+          <a:prstGeom prst="rect">
+            <a:avLst/>
+          </a:prstGeom>
+          <a:noFill/>
+        </p:spPr>
+        <p:txBody>
+          <a:bodyPr wrap="square" lIns="0" rIns="0" tIns="0" bIns="0" anchor="t">
+            <a:spAutoFit/>
+          </a:bodyPr>
+          <a:lstStyle/>
+          <a:p>
+            <a:pPr algn="r"/>
+            <a:r>
+              <a:rPr sz="800" b="0" i="0">
+                <a:solidFill>
+                  <a:srgbClr val="EFEEEE"/>
+                </a:solidFill>
+                <a:latin typeface="Menlo"/>
+              </a:rPr>
+              <a:t>50</a:t>
+            </a:r>
+          </a:p>
+        </p:txBody>
+      </p:sp>
+      <p:sp>
+        <p:nvSpPr>
+          <p:cNvPr id="7" name="TextBox 6"/>
+          <p:cNvSpPr txBox="1"/>
+          <p:nvPr/>
+        </p:nvSpPr>
+        <p:spPr>
+          <a:xfrm>
+            <a:off x="640080" y="566928"/>
+            <a:ext cx="10911535" cy="228600"/>
+          </a:xfrm>
+          <a:prstGeom prst="rect">
+            <a:avLst/>
+          </a:prstGeom>
+          <a:noFill/>
+        </p:spPr>
+        <p:txBody>
+          <a:bodyPr wrap="square" lIns="0" rIns="0" tIns="0" bIns="0" anchor="t">
+            <a:spAutoFit/>
+          </a:bodyPr>
+          <a:lstStyle/>
+          <a:p>
+            <a:pPr algn="ctr"/>
+            <a:r>
+              <a:rPr sz="1000" b="1" i="0" spc="300">
+                <a:solidFill>
+                  <a:srgbClr val="F7D007"/>
+                </a:solidFill>
+                <a:latin typeface="Helvetica Neue"/>
+              </a:rPr>
+              <a:t>Test 01 · PDP</a:t>
+            </a:r>
+          </a:p>
+        </p:txBody>
+      </p:sp>
+      <p:sp>
+        <p:nvSpPr>
+          <p:cNvPr id="8" name="TextBox 7"/>
+          <p:cNvSpPr txBox="1"/>
+          <p:nvPr/>
+        </p:nvSpPr>
+        <p:spPr>
+          <a:xfrm>
+            <a:off x="640080" y="841248"/>
+            <a:ext cx="10911535" cy="640080"/>
+          </a:xfrm>
+          <a:prstGeom prst="rect">
+            <a:avLst/>
+          </a:prstGeom>
+          <a:noFill/>
+        </p:spPr>
+        <p:txBody>
+          <a:bodyPr wrap="square" lIns="0" rIns="0" tIns="0" bIns="0" anchor="t">
+            <a:spAutoFit/>
+          </a:bodyPr>
+          <a:lstStyle/>
+          <a:p>
+            <a:pPr algn="ctr"/>
+            <a:r>
+              <a:rPr sz="3000" b="1" i="0" spc="-50">
+                <a:solidFill>
+                  <a:srgbClr val="FFFFFF"/>
+                </a:solidFill>
+                <a:latin typeface="Helvetica Neue"/>
+              </a:rPr>
+              <a:t>PDP: Lovlighed &amp; tillid</a:t>
+            </a:r>
+          </a:p>
+        </p:txBody>
+      </p:sp>
+      <p:sp>
+        <p:nvSpPr>
+          <p:cNvPr id="9" name="TextBox 8"/>
+          <p:cNvSpPr txBox="1"/>
+          <p:nvPr/>
+        </p:nvSpPr>
+        <p:spPr>
+          <a:xfrm>
+            <a:off x="1828800" y="1463040"/>
+            <a:ext cx="8534095" cy="548640"/>
+          </a:xfrm>
+          <a:prstGeom prst="rect">
+            <a:avLst/>
+          </a:prstGeom>
+          <a:noFill/>
+        </p:spPr>
+        <p:txBody>
+          <a:bodyPr wrap="square" lIns="0" rIns="0" tIns="0" bIns="0" anchor="t">
+            <a:spAutoFit/>
+          </a:bodyPr>
+          <a:lstStyle/>
+          <a:p>
+            <a:pPr algn="ctr"/>
+            <a:r>
+              <a:rPr sz="1200" b="0" i="0">
+                <a:solidFill>
+                  <a:srgbClr val="999999"/>
+                </a:solidFill>
+                <a:latin typeface="Helvetica Neue"/>
+              </a:rPr>
+              <a:t>Hypotese: at besvare "er det lovligt?" ved købsboksen løfter læg i kurv for de førstegangskøbere, som udgør størstedelen af trafikken, fordi Systembolaget-monopolet gør legitimitet til den største indvending.</a:t>
+            </a:r>
+          </a:p>
+        </p:txBody>
+      </p:sp>
+      <p:pic>
+        <p:nvPicPr>
+          <p:cNvPr id="10" name="Picture 9" descr="t1-hifi.jpeg"/>
+          <p:cNvPicPr>
+            <a:picLocks noChangeAspect="1"/>
+          </p:cNvPicPr>
+          <p:nvPr/>
+        </p:nvPicPr>
+        <p:blipFill>
+          <a:blip r:embed="rId3"/>
+          <a:stretch>
+            <a:fillRect/>
+          </a:stretch>
+        </p:blipFill>
+        <p:spPr>
+          <a:xfrm>
+            <a:off x="822960" y="1783080"/>
+            <a:ext cx="2070401" cy="4480560"/>
+          </a:xfrm>
+          <a:prstGeom prst="rect">
+            <a:avLst/>
+          </a:prstGeom>
+        </p:spPr>
+      </p:pic>
+      <p:sp>
+        <p:nvSpPr>
+          <p:cNvPr id="11" name="Rounded Rectangle 10"/>
+          <p:cNvSpPr/>
+          <p:nvPr/>
+        </p:nvSpPr>
+        <p:spPr>
+          <a:xfrm>
+            <a:off x="777240" y="1737360"/>
+            <a:ext cx="2161841" cy="4572000"/>
+          </a:xfrm>
+          <a:prstGeom prst="roundRect">
+            <a:avLst>
+              <a:gd name="adj" fmla="val 4000"/>
+            </a:avLst>
+          </a:prstGeom>
+          <a:noFill/>
+          <a:ln w="19050">
+            <a:solidFill>
+              <a:srgbClr val="303030"/>
+            </a:solidFill>
+          </a:ln>
+        </p:spPr>
+        <p:style>
+          <a:lnRef idx="1">
+            <a:schemeClr val="accent1"/>
+          </a:lnRef>
+          <a:fillRef idx="3">
+            <a:schemeClr val="accent1"/>
+          </a:fillRef>
+          <a:effectRef idx="2">
+            <a:schemeClr val="accent1"/>
+          </a:effectRef>
+          <a:fontRef idx="minor">
+            <a:schemeClr val="lt1"/>
+          </a:fontRef>
+        </p:style>
+        <p:txBody>
+          <a:bodyPr rtlCol="0" anchor="ctr"/>
+          <a:lstStyle/>
+          <a:p>
+            <a:pPr algn="ctr"/>
+          </a:p>
+        </p:txBody>
+      </p:sp>
+      <p:sp>
+        <p:nvSpPr>
+          <p:cNvPr id="12" name="TextBox 11"/>
+          <p:cNvSpPr txBox="1"/>
+          <p:nvPr/>
+        </p:nvSpPr>
+        <p:spPr>
+          <a:xfrm>
+            <a:off x="777240" y="6355080"/>
+            <a:ext cx="2253281" cy="274320"/>
+          </a:xfrm>
+          <a:prstGeom prst="rect">
+            <a:avLst/>
+          </a:prstGeom>
+          <a:noFill/>
+        </p:spPr>
+        <p:txBody>
+          <a:bodyPr wrap="square" lIns="0" rIns="0" tIns="0" bIns="0" anchor="t">
+            <a:spAutoFit/>
+          </a:bodyPr>
+          <a:lstStyle/>
+          <a:p>
+            <a:pPr algn="ctr"/>
+            <a:r>
+              <a:rPr sz="900" b="0" i="0" spc="100">
+                <a:solidFill>
+                  <a:srgbClr val="6B7C75"/>
+                </a:solidFill>
+                <a:latin typeface="Helvetica Neue"/>
+              </a:rPr>
+              <a:t>Variant mocked on the live PDP</a:t>
+            </a:r>
+          </a:p>
+        </p:txBody>
+      </p:sp>
+      <p:sp>
+        <p:nvSpPr>
+          <p:cNvPr id="13" name="Oval 12"/>
+          <p:cNvSpPr/>
+          <p:nvPr/>
+        </p:nvSpPr>
+        <p:spPr>
+          <a:xfrm>
+            <a:off x="3350561" y="1874520"/>
+            <a:ext cx="100584" cy="100584"/>
+          </a:xfrm>
+          <a:prstGeom prst="ellipse">
+            <a:avLst/>
+          </a:prstGeom>
+          <a:solidFill>
+            <a:srgbClr val="22C55E"/>
+          </a:solidFill>
+          <a:ln>
+            <a:noFill/>
+          </a:ln>
+        </p:spPr>
+        <p:style>
+          <a:lnRef idx="1">
+            <a:schemeClr val="accent1"/>
+          </a:lnRef>
+          <a:fillRef idx="3">
+            <a:schemeClr val="accent1"/>
+          </a:fillRef>
+          <a:effectRef idx="2">
+            <a:schemeClr val="accent1"/>
+          </a:effectRef>
+          <a:fontRef idx="minor">
+            <a:schemeClr val="lt1"/>
+          </a:fontRef>
+        </p:style>
+        <p:txBody>
+          <a:bodyPr rtlCol="0" anchor="ctr"/>
+          <a:lstStyle/>
+          <a:p>
+            <a:pPr algn="ctr"/>
+          </a:p>
+        </p:txBody>
+      </p:sp>
+      <p:sp>
+        <p:nvSpPr>
+          <p:cNvPr id="14" name="TextBox 13"/>
+          <p:cNvSpPr txBox="1"/>
+          <p:nvPr/>
+        </p:nvSpPr>
+        <p:spPr>
+          <a:xfrm>
+            <a:off x="3624881" y="1828800"/>
+            <a:ext cx="8018174" cy="822960"/>
+          </a:xfrm>
+          <a:prstGeom prst="rect">
+            <a:avLst/>
+          </a:prstGeom>
+          <a:noFill/>
+        </p:spPr>
+        <p:txBody>
+          <a:bodyPr wrap="square" lIns="0" rIns="0" tIns="0" bIns="0" anchor="t">
+            <a:spAutoFit/>
+          </a:bodyPr>
+          <a:lstStyle/>
+          <a:p>
+            <a:pPr algn="l">
+              <a:lnSpc>
+                <a:spcPct val="105000"/>
+              </a:lnSpc>
+            </a:pPr>
+            <a:r>
+              <a:rPr sz="1100" b="1" i="0">
+                <a:solidFill>
+                  <a:srgbClr val="FFFFFF"/>
+                </a:solidFill>
+                <a:latin typeface="Helvetica Neue"/>
+              </a:rPr>
+              <a:t>En enkel "Är det lagligt? Ja."-blok </a:t>
+            </a:r>
+            <a:r>
+              <a:rPr sz="1100" b="0" i="0">
+                <a:solidFill>
+                  <a:srgbClr val="CCCCCC"/>
+                </a:solidFill>
+                <a:latin typeface="Helvetica Neue"/>
+              </a:rPr>
+              <a:t>under købsboksen: dansk operatør nævnt, Skatteverket-status som fjernsælger, skat og moms allerede inkluderet.</a:t>
+            </a:r>
+          </a:p>
+        </p:txBody>
+      </p:sp>
+      <p:sp>
+        <p:nvSpPr>
+          <p:cNvPr id="15" name="Oval 14"/>
+          <p:cNvSpPr/>
+          <p:nvPr/>
+        </p:nvSpPr>
+        <p:spPr>
+          <a:xfrm>
+            <a:off x="3350561" y="2377440"/>
+            <a:ext cx="100584" cy="100584"/>
+          </a:xfrm>
+          <a:prstGeom prst="ellipse">
+            <a:avLst/>
+          </a:prstGeom>
+          <a:solidFill>
+            <a:srgbClr val="22C55E"/>
+          </a:solidFill>
+          <a:ln>
+            <a:noFill/>
+          </a:ln>
+        </p:spPr>
+        <p:style>
+          <a:lnRef idx="1">
+            <a:schemeClr val="accent1"/>
+          </a:lnRef>
+          <a:fillRef idx="3">
+            <a:schemeClr val="accent1"/>
+          </a:fillRef>
+          <a:effectRef idx="2">
+            <a:schemeClr val="accent1"/>
+          </a:effectRef>
+          <a:fontRef idx="minor">
+            <a:schemeClr val="lt1"/>
+          </a:fontRef>
+        </p:style>
+        <p:txBody>
+          <a:bodyPr rtlCol="0" anchor="ctr"/>
+          <a:lstStyle/>
+          <a:p>
+            <a:pPr algn="ctr"/>
+          </a:p>
+        </p:txBody>
+      </p:sp>
+      <p:sp>
+        <p:nvSpPr>
+          <p:cNvPr id="16" name="TextBox 15"/>
+          <p:cNvSpPr txBox="1"/>
+          <p:nvPr/>
+        </p:nvSpPr>
+        <p:spPr>
+          <a:xfrm>
+            <a:off x="3624881" y="2331720"/>
+            <a:ext cx="8018174" cy="822960"/>
+          </a:xfrm>
+          <a:prstGeom prst="rect">
+            <a:avLst/>
+          </a:prstGeom>
+          <a:noFill/>
+        </p:spPr>
+        <p:txBody>
+          <a:bodyPr wrap="square" lIns="0" rIns="0" tIns="0" bIns="0" anchor="t">
+            <a:spAutoFit/>
+          </a:bodyPr>
+          <a:lstStyle/>
+          <a:p>
+            <a:pPr algn="l">
+              <a:lnSpc>
+                <a:spcPct val="105000"/>
+              </a:lnSpc>
+            </a:pPr>
+            <a:r>
+              <a:rPr sz="1100" b="1" i="0">
+                <a:solidFill>
+                  <a:srgbClr val="FFFFFF"/>
+                </a:solidFill>
+                <a:latin typeface="Helvetica Neue"/>
+              </a:rPr>
+              <a:t>Trustpilot-bevis flyttet til beslutningspunktet, </a:t>
+            </a:r>
+            <a:r>
+              <a:rPr sz="1100" b="0" i="0">
+                <a:solidFill>
+                  <a:srgbClr val="CCCCCC"/>
+                </a:solidFill>
+                <a:latin typeface="Helvetica Neue"/>
+              </a:rPr>
+              <a:t>de ægte 4,7 på 5,985 anmeldelser, et Trygg e-handel-mærke, og alderskontrollen fremstillet som tryghed, ikke en barriere.</a:t>
+            </a:r>
+          </a:p>
+        </p:txBody>
+      </p:sp>
+      <p:sp>
+        <p:nvSpPr>
+          <p:cNvPr id="17" name="Oval 16"/>
+          <p:cNvSpPr/>
+          <p:nvPr/>
+        </p:nvSpPr>
+        <p:spPr>
+          <a:xfrm>
+            <a:off x="3350561" y="2880360"/>
+            <a:ext cx="100584" cy="100584"/>
+          </a:xfrm>
+          <a:prstGeom prst="ellipse">
+            <a:avLst/>
+          </a:prstGeom>
+          <a:solidFill>
+            <a:srgbClr val="22C55E"/>
+          </a:solidFill>
+          <a:ln>
+            <a:noFill/>
+          </a:ln>
+        </p:spPr>
+        <p:style>
+          <a:lnRef idx="1">
+            <a:schemeClr val="accent1"/>
+          </a:lnRef>
+          <a:fillRef idx="3">
+            <a:schemeClr val="accent1"/>
+          </a:fillRef>
+          <a:effectRef idx="2">
+            <a:schemeClr val="accent1"/>
+          </a:effectRef>
+          <a:fontRef idx="minor">
+            <a:schemeClr val="lt1"/>
+          </a:fontRef>
+        </p:style>
+        <p:txBody>
+          <a:bodyPr rtlCol="0" anchor="ctr"/>
+          <a:lstStyle/>
+          <a:p>
+            <a:pPr algn="ctr"/>
+          </a:p>
+        </p:txBody>
+      </p:sp>
+      <p:sp>
+        <p:nvSpPr>
+          <p:cNvPr id="18" name="TextBox 17"/>
+          <p:cNvSpPr txBox="1"/>
+          <p:nvPr/>
+        </p:nvSpPr>
+        <p:spPr>
+          <a:xfrm>
+            <a:off x="3624881" y="2834640"/>
+            <a:ext cx="8018174" cy="822960"/>
+          </a:xfrm>
+          <a:prstGeom prst="rect">
+            <a:avLst/>
+          </a:prstGeom>
+          <a:noFill/>
+        </p:spPr>
+        <p:txBody>
+          <a:bodyPr wrap="square" lIns="0" rIns="0" tIns="0" bIns="0" anchor="t">
+            <a:spAutoFit/>
+          </a:bodyPr>
+          <a:lstStyle/>
+          <a:p>
+            <a:pPr algn="l">
+              <a:lnSpc>
+                <a:spcPct val="105000"/>
+              </a:lnSpc>
+            </a:pPr>
+            <a:r>
+              <a:rPr sz="1100" b="1" i="0">
+                <a:solidFill>
+                  <a:srgbClr val="FFFFFF"/>
+                </a:solidFill>
+                <a:latin typeface="Helvetica Neue"/>
+              </a:rPr>
+              <a:t>Ærlig leveringslinje </a:t>
+            </a:r>
+            <a:r>
+              <a:rPr sz="1100" b="0" i="0">
+                <a:solidFill>
+                  <a:srgbClr val="CCCCCC"/>
+                </a:solidFill>
+                <a:latin typeface="Helvetica Neue"/>
+              </a:rPr>
+              <a:t>(2 til 5 arbetsdagar) erstatter det vage "snabb hemleverans", plus en pris per flaske for at ramme værdien.</a:t>
+            </a:r>
+          </a:p>
+        </p:txBody>
+      </p:sp>
+    </p:spTree>
+  </p:cSld>
+  <p:clrMapOvr>
+    <a:masterClrMapping/>
+  </p:clrMapOvr>
+</p:sld>
+</file>
+
+<file path=ppt/slides/slide52.xml><?xml version="1.0" encoding="utf-8"?>
+<p:sld xmlns:a="http://schemas.openxmlformats.org/drawingml/2006/main" xmlns:p="http://schemas.openxmlformats.org/presentationml/2006/main" xmlns:r="http://schemas.openxmlformats.org/officeDocument/2006/relationships">
+  <p:cSld>
+    <p:spTree>
+      <p:nvGrpSpPr>
+        <p:cNvPr id="1" name=""/>
+        <p:cNvGrpSpPr/>
+        <p:nvPr/>
+      </p:nvGrpSpPr>
+      <p:grpSpPr/>
+      <p:sp>
+        <p:nvSpPr>
+          <p:cNvPr id="2" name="Rectangle 1"/>
+          <p:cNvSpPr/>
+          <p:nvPr/>
+        </p:nvSpPr>
+        <p:spPr>
+          <a:xfrm>
+            <a:off x="0" y="0"/>
+            <a:ext cx="12191695" cy="6858000"/>
+          </a:xfrm>
+          <a:prstGeom prst="rect">
+            <a:avLst/>
+          </a:prstGeom>
+          <a:solidFill>
+            <a:srgbClr val="000000"/>
+          </a:solidFill>
+          <a:ln>
+            <a:noFill/>
+          </a:ln>
+        </p:spPr>
+        <p:style>
+          <a:lnRef idx="1">
+            <a:schemeClr val="accent1"/>
+          </a:lnRef>
+          <a:fillRef idx="3">
+            <a:schemeClr val="accent1"/>
+          </a:fillRef>
+          <a:effectRef idx="2">
+            <a:schemeClr val="accent1"/>
+          </a:effectRef>
+          <a:fontRef idx="minor">
+            <a:schemeClr val="lt1"/>
+          </a:fontRef>
+        </p:style>
+        <p:txBody>
+          <a:bodyPr rtlCol="0" anchor="ctr"/>
+          <a:lstStyle/>
+          <a:p>
+            <a:pPr algn="ctr"/>
+          </a:p>
+        </p:txBody>
+      </p:sp>
+      <p:pic>
+        <p:nvPicPr>
+          <p:cNvPr id="3" name="Picture 2" descr="ecomhouse-wordmark.png"/>
+          <p:cNvPicPr>
+            <a:picLocks noChangeAspect="1"/>
+          </p:cNvPicPr>
+          <p:nvPr/>
+        </p:nvPicPr>
+        <p:blipFill>
+          <a:blip r:embed="rId2"/>
+          <a:stretch>
+            <a:fillRect/>
+          </a:stretch>
+        </p:blipFill>
+        <p:spPr>
+          <a:xfrm>
+            <a:off x="292608" y="201168"/>
+            <a:ext cx="1873736" cy="201168"/>
+          </a:xfrm>
+          <a:prstGeom prst="rect">
+            <a:avLst/>
+          </a:prstGeom>
+        </p:spPr>
+      </p:pic>
+      <p:sp>
+        <p:nvSpPr>
+          <p:cNvPr id="4" name="TextBox 3"/>
+          <p:cNvSpPr txBox="1"/>
+          <p:nvPr/>
+        </p:nvSpPr>
+        <p:spPr>
+          <a:xfrm>
+            <a:off x="11475720" y="201168"/>
+            <a:ext cx="548640" cy="274320"/>
+          </a:xfrm>
+          <a:prstGeom prst="rect">
+            <a:avLst/>
+          </a:prstGeom>
+          <a:noFill/>
+        </p:spPr>
+        <p:txBody>
+          <a:bodyPr wrap="square" lIns="0" rIns="0" tIns="0" bIns="0" anchor="t">
+            <a:spAutoFit/>
+          </a:bodyPr>
+          <a:lstStyle/>
+          <a:p>
+            <a:pPr algn="r"/>
+            <a:r>
+              <a:rPr sz="1000" b="0" i="0">
+                <a:solidFill>
+                  <a:srgbClr val="EFEEEE"/>
+                </a:solidFill>
+                <a:latin typeface="Helvetica Neue"/>
+              </a:rPr>
+              <a:t>2026</a:t>
+            </a:r>
+          </a:p>
+        </p:txBody>
+      </p:sp>
+      <p:sp>
+        <p:nvSpPr>
+          <p:cNvPr id="5" name="TextBox 4"/>
+          <p:cNvSpPr txBox="1"/>
+          <p:nvPr/>
+        </p:nvSpPr>
+        <p:spPr>
+          <a:xfrm>
+            <a:off x="292608" y="6565392"/>
+            <a:ext cx="4114800" cy="228600"/>
+          </a:xfrm>
+          <a:prstGeom prst="rect">
+            <a:avLst/>
+          </a:prstGeom>
+          <a:noFill/>
+        </p:spPr>
+        <p:txBody>
+          <a:bodyPr wrap="square" lIns="0" rIns="0" tIns="0" bIns="0" anchor="t">
+            <a:spAutoFit/>
+          </a:bodyPr>
+          <a:lstStyle/>
+          <a:p>
+            <a:pPr algn="l"/>
+            <a:r>
+              <a:rPr sz="800" b="0" i="0" spc="150">
+                <a:solidFill>
+                  <a:srgbClr val="EFEEEE"/>
+                </a:solidFill>
+                <a:latin typeface="Helvetica Neue"/>
+              </a:rPr>
+              <a:t>ECOMHOUSE ©ALL RIGHTS RESERVED</a:t>
+            </a:r>
+          </a:p>
+        </p:txBody>
+      </p:sp>
+      <p:sp>
+        <p:nvSpPr>
+          <p:cNvPr id="6" name="TextBox 5"/>
+          <p:cNvSpPr txBox="1"/>
+          <p:nvPr/>
+        </p:nvSpPr>
+        <p:spPr>
+          <a:xfrm>
+            <a:off x="11475720" y="6565392"/>
+            <a:ext cx="548640" cy="228600"/>
+          </a:xfrm>
+          <a:prstGeom prst="rect">
+            <a:avLst/>
+          </a:prstGeom>
+          <a:noFill/>
+        </p:spPr>
+        <p:txBody>
+          <a:bodyPr wrap="square" lIns="0" rIns="0" tIns="0" bIns="0" anchor="t">
+            <a:spAutoFit/>
+          </a:bodyPr>
+          <a:lstStyle/>
+          <a:p>
+            <a:pPr algn="r"/>
+            <a:r>
+              <a:rPr sz="800" b="0" i="0">
+                <a:solidFill>
+                  <a:srgbClr val="EFEEEE"/>
+                </a:solidFill>
+                <a:latin typeface="Menlo"/>
+              </a:rPr>
+              <a:t>51</a:t>
+            </a:r>
+          </a:p>
+        </p:txBody>
+      </p:sp>
+      <p:sp>
+        <p:nvSpPr>
+          <p:cNvPr id="7" name="TextBox 6"/>
+          <p:cNvSpPr txBox="1"/>
+          <p:nvPr/>
+        </p:nvSpPr>
+        <p:spPr>
+          <a:xfrm>
+            <a:off x="640080" y="566928"/>
+            <a:ext cx="10911535" cy="228600"/>
+          </a:xfrm>
+          <a:prstGeom prst="rect">
+            <a:avLst/>
+          </a:prstGeom>
+          <a:noFill/>
+        </p:spPr>
+        <p:txBody>
+          <a:bodyPr wrap="square" lIns="0" rIns="0" tIns="0" bIns="0" anchor="t">
+            <a:spAutoFit/>
+          </a:bodyPr>
+          <a:lstStyle/>
+          <a:p>
+            <a:pPr algn="ctr"/>
+            <a:r>
+              <a:rPr sz="1000" b="1" i="0" spc="300">
+                <a:solidFill>
+                  <a:srgbClr val="F7D007"/>
+                </a:solidFill>
+                <a:latin typeface="Helvetica Neue"/>
+              </a:rPr>
+              <a:t>Test 02 · Kurv</a:t>
+            </a:r>
+          </a:p>
+        </p:txBody>
+      </p:sp>
+      <p:sp>
+        <p:nvSpPr>
+          <p:cNvPr id="8" name="TextBox 7"/>
+          <p:cNvSpPr txBox="1"/>
+          <p:nvPr/>
+        </p:nvSpPr>
+        <p:spPr>
+          <a:xfrm>
+            <a:off x="640080" y="841248"/>
+            <a:ext cx="10911535" cy="640080"/>
+          </a:xfrm>
+          <a:prstGeom prst="rect">
+            <a:avLst/>
+          </a:prstGeom>
+          <a:noFill/>
+        </p:spPr>
+        <p:txBody>
+          <a:bodyPr wrap="square" lIns="0" rIns="0" tIns="0" bIns="0" anchor="t">
+            <a:spAutoFit/>
+          </a:bodyPr>
+          <a:lstStyle/>
+          <a:p>
+            <a:pPr algn="ctr"/>
+            <a:r>
+              <a:rPr sz="3000" b="1" i="0" spc="-50">
+                <a:solidFill>
+                  <a:srgbClr val="FFFFFF"/>
+                </a:solidFill>
+                <a:latin typeface="Helvetica Neue"/>
+              </a:rPr>
+              <a:t>Kurv: leveringsklarhed &amp; checkout</a:t>
+            </a:r>
+          </a:p>
+        </p:txBody>
+      </p:sp>
+      <p:sp>
+        <p:nvSpPr>
+          <p:cNvPr id="9" name="TextBox 8"/>
+          <p:cNvSpPr txBox="1"/>
+          <p:nvPr/>
+        </p:nvSpPr>
+        <p:spPr>
+          <a:xfrm>
+            <a:off x="1828800" y="1463040"/>
+            <a:ext cx="8534095" cy="548640"/>
+          </a:xfrm>
+          <a:prstGeom prst="rect">
+            <a:avLst/>
+          </a:prstGeom>
+          <a:noFill/>
+        </p:spPr>
+        <p:txBody>
+          <a:bodyPr wrap="square" lIns="0" rIns="0" tIns="0" bIns="0" anchor="t">
+            <a:spAutoFit/>
+          </a:bodyPr>
+          <a:lstStyle/>
+          <a:p>
+            <a:pPr algn="ctr"/>
+            <a:r>
+              <a:rPr sz="1200" b="0" i="0">
+                <a:solidFill>
+                  <a:srgbClr val="999999"/>
+                </a:solidFill>
+                <a:latin typeface="Helvetica Neue"/>
+              </a:rPr>
+              <a:t>Hypotese: at fjerne usikkerhed om fragt og levering inde i kurven genvinder det største læk, hvor de fleste sessioner, der når checkout, aldrig gennemføres.</a:t>
+            </a:r>
+          </a:p>
+        </p:txBody>
+      </p:sp>
+      <p:pic>
+        <p:nvPicPr>
+          <p:cNvPr id="10" name="Picture 9" descr="t2-hifi.jpeg"/>
+          <p:cNvPicPr>
+            <a:picLocks noChangeAspect="1"/>
+          </p:cNvPicPr>
+          <p:nvPr/>
+        </p:nvPicPr>
+        <p:blipFill>
+          <a:blip r:embed="rId3"/>
+          <a:stretch>
+            <a:fillRect/>
+          </a:stretch>
+        </p:blipFill>
+        <p:spPr>
+          <a:xfrm>
+            <a:off x="822960" y="1783080"/>
+            <a:ext cx="2070401" cy="4480560"/>
+          </a:xfrm>
+          <a:prstGeom prst="rect">
+            <a:avLst/>
+          </a:prstGeom>
+        </p:spPr>
+      </p:pic>
+      <p:sp>
+        <p:nvSpPr>
+          <p:cNvPr id="11" name="Rounded Rectangle 10"/>
+          <p:cNvSpPr/>
+          <p:nvPr/>
+        </p:nvSpPr>
+        <p:spPr>
+          <a:xfrm>
+            <a:off x="777240" y="1737360"/>
+            <a:ext cx="2161841" cy="4572000"/>
+          </a:xfrm>
+          <a:prstGeom prst="roundRect">
+            <a:avLst>
+              <a:gd name="adj" fmla="val 4000"/>
+            </a:avLst>
+          </a:prstGeom>
+          <a:noFill/>
+          <a:ln w="19050">
+            <a:solidFill>
+              <a:srgbClr val="303030"/>
+            </a:solidFill>
+          </a:ln>
+        </p:spPr>
+        <p:style>
+          <a:lnRef idx="1">
+            <a:schemeClr val="accent1"/>
+          </a:lnRef>
+          <a:fillRef idx="3">
+            <a:schemeClr val="accent1"/>
+          </a:fillRef>
+          <a:effectRef idx="2">
+            <a:schemeClr val="accent1"/>
+          </a:effectRef>
+          <a:fontRef idx="minor">
+            <a:schemeClr val="lt1"/>
+          </a:fontRef>
+        </p:style>
+        <p:txBody>
+          <a:bodyPr rtlCol="0" anchor="ctr"/>
+          <a:lstStyle/>
+          <a:p>
+            <a:pPr algn="ctr"/>
+          </a:p>
+        </p:txBody>
+      </p:sp>
+      <p:sp>
+        <p:nvSpPr>
+          <p:cNvPr id="12" name="TextBox 11"/>
+          <p:cNvSpPr txBox="1"/>
+          <p:nvPr/>
+        </p:nvSpPr>
+        <p:spPr>
+          <a:xfrm>
+            <a:off x="777240" y="6355080"/>
+            <a:ext cx="2253281" cy="274320"/>
+          </a:xfrm>
+          <a:prstGeom prst="rect">
+            <a:avLst/>
+          </a:prstGeom>
+          <a:noFill/>
+        </p:spPr>
+        <p:txBody>
+          <a:bodyPr wrap="square" lIns="0" rIns="0" tIns="0" bIns="0" anchor="t">
+            <a:spAutoFit/>
+          </a:bodyPr>
+          <a:lstStyle/>
+          <a:p>
+            <a:pPr algn="ctr"/>
+            <a:r>
+              <a:rPr sz="900" b="0" i="0" spc="100">
+                <a:solidFill>
+                  <a:srgbClr val="6B7C75"/>
+                </a:solidFill>
+                <a:latin typeface="Helvetica Neue"/>
+              </a:rPr>
+              <a:t>Variant cart drawer, mocked on the live store</a:t>
+            </a:r>
+          </a:p>
+        </p:txBody>
+      </p:sp>
+      <p:sp>
+        <p:nvSpPr>
+          <p:cNvPr id="13" name="Oval 12"/>
+          <p:cNvSpPr/>
+          <p:nvPr/>
+        </p:nvSpPr>
+        <p:spPr>
+          <a:xfrm>
+            <a:off x="3350561" y="1874520"/>
+            <a:ext cx="100584" cy="100584"/>
+          </a:xfrm>
+          <a:prstGeom prst="ellipse">
+            <a:avLst/>
+          </a:prstGeom>
+          <a:solidFill>
+            <a:srgbClr val="22C55E"/>
+          </a:solidFill>
+          <a:ln>
+            <a:noFill/>
+          </a:ln>
+        </p:spPr>
+        <p:style>
+          <a:lnRef idx="1">
+            <a:schemeClr val="accent1"/>
+          </a:lnRef>
+          <a:fillRef idx="3">
+            <a:schemeClr val="accent1"/>
+          </a:fillRef>
+          <a:effectRef idx="2">
+            <a:schemeClr val="accent1"/>
+          </a:effectRef>
+          <a:fontRef idx="minor">
+            <a:schemeClr val="lt1"/>
+          </a:fontRef>
+        </p:style>
+        <p:txBody>
+          <a:bodyPr rtlCol="0" anchor="ctr"/>
+          <a:lstStyle/>
+          <a:p>
+            <a:pPr algn="ctr"/>
+          </a:p>
+        </p:txBody>
+      </p:sp>
+      <p:sp>
+        <p:nvSpPr>
+          <p:cNvPr id="14" name="TextBox 13"/>
+          <p:cNvSpPr txBox="1"/>
+          <p:nvPr/>
+        </p:nvSpPr>
+        <p:spPr>
+          <a:xfrm>
+            <a:off x="3624881" y="1828800"/>
+            <a:ext cx="8018174" cy="822960"/>
+          </a:xfrm>
+          <a:prstGeom prst="rect">
+            <a:avLst/>
+          </a:prstGeom>
+          <a:noFill/>
+        </p:spPr>
+        <p:txBody>
+          <a:bodyPr wrap="square" lIns="0" rIns="0" tIns="0" bIns="0" anchor="t">
+            <a:spAutoFit/>
+          </a:bodyPr>
+          <a:lstStyle/>
+          <a:p>
+            <a:pPr algn="l">
+              <a:lnSpc>
+                <a:spcPct val="105000"/>
+              </a:lnSpc>
+            </a:pPr>
+            <a:r>
+              <a:rPr sz="1100" b="1" i="0">
+                <a:solidFill>
+                  <a:srgbClr val="FFFFFF"/>
+                </a:solidFill>
+                <a:latin typeface="Helvetica Neue"/>
+              </a:rPr>
+              <a:t>Ærlig leveringsblok </a:t>
+            </a:r>
+            <a:r>
+              <a:rPr sz="1100" b="0" i="0">
+                <a:solidFill>
+                  <a:srgbClr val="CCCCCC"/>
+                </a:solidFill>
+                <a:latin typeface="Helvetica Neue"/>
+              </a:rPr>
+              <a:t>med et interval på 2 til 5 dage og et løfte om, at du vælger dagen, der erstatter påstanden "1-3 dagar" bag 86% af klagerne.</a:t>
+            </a:r>
+          </a:p>
+        </p:txBody>
+      </p:sp>
+      <p:sp>
+        <p:nvSpPr>
+          <p:cNvPr id="15" name="Oval 14"/>
+          <p:cNvSpPr/>
+          <p:nvPr/>
+        </p:nvSpPr>
+        <p:spPr>
+          <a:xfrm>
+            <a:off x="3350561" y="2377440"/>
+            <a:ext cx="100584" cy="100584"/>
+          </a:xfrm>
+          <a:prstGeom prst="ellipse">
+            <a:avLst/>
+          </a:prstGeom>
+          <a:solidFill>
+            <a:srgbClr val="22C55E"/>
+          </a:solidFill>
+          <a:ln>
+            <a:noFill/>
+          </a:ln>
+        </p:spPr>
+        <p:style>
+          <a:lnRef idx="1">
+            <a:schemeClr val="accent1"/>
+          </a:lnRef>
+          <a:fillRef idx="3">
+            <a:schemeClr val="accent1"/>
+          </a:fillRef>
+          <a:effectRef idx="2">
+            <a:schemeClr val="accent1"/>
+          </a:effectRef>
+          <a:fontRef idx="minor">
+            <a:schemeClr val="lt1"/>
+          </a:fontRef>
+        </p:style>
+        <p:txBody>
+          <a:bodyPr rtlCol="0" anchor="ctr"/>
+          <a:lstStyle/>
+          <a:p>
+            <a:pPr algn="ctr"/>
+          </a:p>
+        </p:txBody>
+      </p:sp>
+      <p:sp>
+        <p:nvSpPr>
+          <p:cNvPr id="16" name="TextBox 15"/>
+          <p:cNvSpPr txBox="1"/>
+          <p:nvPr/>
+        </p:nvSpPr>
+        <p:spPr>
+          <a:xfrm>
+            <a:off x="3624881" y="2331720"/>
+            <a:ext cx="8018174" cy="822960"/>
+          </a:xfrm>
+          <a:prstGeom prst="rect">
+            <a:avLst/>
+          </a:prstGeom>
+          <a:noFill/>
+        </p:spPr>
+        <p:txBody>
+          <a:bodyPr wrap="square" lIns="0" rIns="0" tIns="0" bIns="0" anchor="t">
+            <a:spAutoFit/>
+          </a:bodyPr>
+          <a:lstStyle/>
+          <a:p>
+            <a:pPr algn="l">
+              <a:lnSpc>
+                <a:spcPct val="105000"/>
+              </a:lnSpc>
+            </a:pPr>
+            <a:r>
+              <a:rPr sz="1100" b="1" i="0">
+                <a:solidFill>
+                  <a:srgbClr val="FFFFFF"/>
+                </a:solidFill>
+                <a:latin typeface="Helvetica Neue"/>
+              </a:rPr>
+              <a:t>Gratis fragt gjort utvetydig, </a:t>
+            </a:r>
+            <a:r>
+              <a:rPr sz="1100" b="0" i="0">
+                <a:solidFill>
+                  <a:srgbClr val="CCCCCC"/>
+                </a:solidFill>
+                <a:latin typeface="Helvetica Neue"/>
+              </a:rPr>
+              <a:t>Airmee-betingelsen oplyst på forhånd og gentaget ved totalen, så intet overraskelsesgebyr senere.</a:t>
+            </a:r>
+          </a:p>
+        </p:txBody>
+      </p:sp>
+      <p:sp>
+        <p:nvSpPr>
+          <p:cNvPr id="17" name="Oval 16"/>
+          <p:cNvSpPr/>
+          <p:nvPr/>
+        </p:nvSpPr>
+        <p:spPr>
+          <a:xfrm>
+            <a:off x="3350561" y="2880360"/>
+            <a:ext cx="100584" cy="100584"/>
+          </a:xfrm>
+          <a:prstGeom prst="ellipse">
+            <a:avLst/>
+          </a:prstGeom>
+          <a:solidFill>
+            <a:srgbClr val="22C55E"/>
+          </a:solidFill>
+          <a:ln>
+            <a:noFill/>
+          </a:ln>
+        </p:spPr>
+        <p:style>
+          <a:lnRef idx="1">
+            <a:schemeClr val="accent1"/>
+          </a:lnRef>
+          <a:fillRef idx="3">
+            <a:schemeClr val="accent1"/>
+          </a:fillRef>
+          <a:effectRef idx="2">
+            <a:schemeClr val="accent1"/>
+          </a:effectRef>
+          <a:fontRef idx="minor">
+            <a:schemeClr val="lt1"/>
+          </a:fontRef>
+        </p:style>
+        <p:txBody>
+          <a:bodyPr rtlCol="0" anchor="ctr"/>
+          <a:lstStyle/>
+          <a:p>
+            <a:pPr algn="ctr"/>
+          </a:p>
+        </p:txBody>
+      </p:sp>
+      <p:sp>
+        <p:nvSpPr>
+          <p:cNvPr id="18" name="TextBox 17"/>
+          <p:cNvSpPr txBox="1"/>
+          <p:nvPr/>
+        </p:nvSpPr>
+        <p:spPr>
+          <a:xfrm>
+            <a:off x="3624881" y="2834640"/>
+            <a:ext cx="8018174" cy="822960"/>
+          </a:xfrm>
+          <a:prstGeom prst="rect">
+            <a:avLst/>
+          </a:prstGeom>
+          <a:noFill/>
+        </p:spPr>
+        <p:txBody>
+          <a:bodyPr wrap="square" lIns="0" rIns="0" tIns="0" bIns="0" anchor="t">
+            <a:spAutoFit/>
+          </a:bodyPr>
+          <a:lstStyle/>
+          <a:p>
+            <a:pPr algn="l">
+              <a:lnSpc>
+                <a:spcPct val="105000"/>
+              </a:lnSpc>
+            </a:pPr>
+            <a:r>
+              <a:rPr sz="1100" b="1" i="0">
+                <a:solidFill>
+                  <a:srgbClr val="FFFFFF"/>
+                </a:solidFill>
+                <a:latin typeface="Helvetica Neue"/>
+              </a:rPr>
+              <a:t>Tillid i betalingsøjeblikket, </a:t>
+            </a:r>
+            <a:r>
+              <a:rPr sz="1100" b="0" i="0">
+                <a:solidFill>
+                  <a:srgbClr val="CCCCCC"/>
+                </a:solidFill>
+                <a:latin typeface="Helvetica Neue"/>
+              </a:rPr>
+              <a:t>skat og moms inkluderet, Klarna- og kortmærker, "trygg betalning", lige før checkout.</a:t>
+            </a:r>
+          </a:p>
+        </p:txBody>
+      </p:sp>
+    </p:spTree>
+  </p:cSld>
+  <p:clrMapOvr>
+    <a:masterClrMapping/>
+  </p:clrMapOvr>
+</p:sld>
+</file>
+
+<file path=ppt/slides/slide53.xml><?xml version="1.0" encoding="utf-8"?>
+<p:sld xmlns:a="http://schemas.openxmlformats.org/drawingml/2006/main" xmlns:p="http://schemas.openxmlformats.org/presentationml/2006/main" xmlns:r="http://schemas.openxmlformats.org/officeDocument/2006/relationships">
+  <p:cSld>
+    <p:spTree>
+      <p:nvGrpSpPr>
+        <p:cNvPr id="1" name=""/>
+        <p:cNvGrpSpPr/>
+        <p:nvPr/>
+      </p:nvGrpSpPr>
+      <p:grpSpPr/>
+      <p:sp>
+        <p:nvSpPr>
+          <p:cNvPr id="2" name="Rectangle 1"/>
+          <p:cNvSpPr/>
+          <p:nvPr/>
+        </p:nvSpPr>
+        <p:spPr>
+          <a:xfrm>
+            <a:off x="0" y="0"/>
+            <a:ext cx="12191695" cy="6858000"/>
+          </a:xfrm>
+          <a:prstGeom prst="rect">
+            <a:avLst/>
+          </a:prstGeom>
+          <a:solidFill>
+            <a:srgbClr val="000000"/>
+          </a:solidFill>
+          <a:ln>
+            <a:noFill/>
+          </a:ln>
+        </p:spPr>
+        <p:style>
+          <a:lnRef idx="1">
+            <a:schemeClr val="accent1"/>
+          </a:lnRef>
+          <a:fillRef idx="3">
+            <a:schemeClr val="accent1"/>
+          </a:fillRef>
+          <a:effectRef idx="2">
+            <a:schemeClr val="accent1"/>
+          </a:effectRef>
+          <a:fontRef idx="minor">
+            <a:schemeClr val="lt1"/>
+          </a:fontRef>
+        </p:style>
+        <p:txBody>
+          <a:bodyPr rtlCol="0" anchor="ctr"/>
+          <a:lstStyle/>
+          <a:p>
+            <a:pPr algn="ctr"/>
+          </a:p>
+        </p:txBody>
+      </p:sp>
+      <p:pic>
+        <p:nvPicPr>
+          <p:cNvPr id="3" name="Picture 2" descr="ecomhouse-wordmark.png"/>
+          <p:cNvPicPr>
+            <a:picLocks noChangeAspect="1"/>
+          </p:cNvPicPr>
+          <p:nvPr/>
+        </p:nvPicPr>
+        <p:blipFill>
+          <a:blip r:embed="rId2"/>
+          <a:stretch>
+            <a:fillRect/>
+          </a:stretch>
+        </p:blipFill>
+        <p:spPr>
+          <a:xfrm>
+            <a:off x="292608" y="201168"/>
+            <a:ext cx="1873736" cy="201168"/>
+          </a:xfrm>
+          <a:prstGeom prst="rect">
+            <a:avLst/>
+          </a:prstGeom>
+        </p:spPr>
+      </p:pic>
+      <p:sp>
+        <p:nvSpPr>
+          <p:cNvPr id="4" name="TextBox 3"/>
+          <p:cNvSpPr txBox="1"/>
+          <p:nvPr/>
+        </p:nvSpPr>
+        <p:spPr>
+          <a:xfrm>
+            <a:off x="11475720" y="201168"/>
+            <a:ext cx="548640" cy="274320"/>
+          </a:xfrm>
+          <a:prstGeom prst="rect">
+            <a:avLst/>
+          </a:prstGeom>
+          <a:noFill/>
+        </p:spPr>
+        <p:txBody>
+          <a:bodyPr wrap="square" lIns="0" rIns="0" tIns="0" bIns="0" anchor="t">
+            <a:spAutoFit/>
+          </a:bodyPr>
+          <a:lstStyle/>
+          <a:p>
+            <a:pPr algn="r"/>
+            <a:r>
+              <a:rPr sz="1000" b="0" i="0">
+                <a:solidFill>
+                  <a:srgbClr val="EFEEEE"/>
+                </a:solidFill>
+                <a:latin typeface="Helvetica Neue"/>
+              </a:rPr>
+              <a:t>2026</a:t>
+            </a:r>
+          </a:p>
+        </p:txBody>
+      </p:sp>
+      <p:sp>
+        <p:nvSpPr>
+          <p:cNvPr id="5" name="TextBox 4"/>
+          <p:cNvSpPr txBox="1"/>
+          <p:nvPr/>
+        </p:nvSpPr>
+        <p:spPr>
+          <a:xfrm>
+            <a:off x="292608" y="6565392"/>
+            <a:ext cx="4114800" cy="228600"/>
+          </a:xfrm>
+          <a:prstGeom prst="rect">
+            <a:avLst/>
+          </a:prstGeom>
+          <a:noFill/>
+        </p:spPr>
+        <p:txBody>
+          <a:bodyPr wrap="square" lIns="0" rIns="0" tIns="0" bIns="0" anchor="t">
+            <a:spAutoFit/>
+          </a:bodyPr>
+          <a:lstStyle/>
+          <a:p>
+            <a:pPr algn="l"/>
+            <a:r>
+              <a:rPr sz="800" b="0" i="0" spc="150">
+                <a:solidFill>
+                  <a:srgbClr val="EFEEEE"/>
+                </a:solidFill>
+                <a:latin typeface="Helvetica Neue"/>
+              </a:rPr>
+              <a:t>ECOMHOUSE ©ALL RIGHTS RESERVED</a:t>
+            </a:r>
+          </a:p>
+        </p:txBody>
+      </p:sp>
+      <p:sp>
+        <p:nvSpPr>
+          <p:cNvPr id="6" name="TextBox 5"/>
+          <p:cNvSpPr txBox="1"/>
+          <p:nvPr/>
+        </p:nvSpPr>
+        <p:spPr>
+          <a:xfrm>
+            <a:off x="11475720" y="6565392"/>
+            <a:ext cx="548640" cy="228600"/>
+          </a:xfrm>
+          <a:prstGeom prst="rect">
+            <a:avLst/>
+          </a:prstGeom>
+          <a:noFill/>
+        </p:spPr>
+        <p:txBody>
+          <a:bodyPr wrap="square" lIns="0" rIns="0" tIns="0" bIns="0" anchor="t">
+            <a:spAutoFit/>
+          </a:bodyPr>
+          <a:lstStyle/>
+          <a:p>
+            <a:pPr algn="r"/>
+            <a:r>
+              <a:rPr sz="800" b="0" i="0">
+                <a:solidFill>
+                  <a:srgbClr val="EFEEEE"/>
+                </a:solidFill>
+                <a:latin typeface="Menlo"/>
+              </a:rPr>
+              <a:t>52</a:t>
+            </a:r>
+          </a:p>
+        </p:txBody>
+      </p:sp>
+      <p:sp>
+        <p:nvSpPr>
+          <p:cNvPr id="7" name="TextBox 6"/>
+          <p:cNvSpPr txBox="1"/>
+          <p:nvPr/>
+        </p:nvSpPr>
+        <p:spPr>
+          <a:xfrm>
+            <a:off x="640080" y="566928"/>
+            <a:ext cx="10911535" cy="228600"/>
+          </a:xfrm>
+          <a:prstGeom prst="rect">
+            <a:avLst/>
+          </a:prstGeom>
+          <a:noFill/>
+        </p:spPr>
+        <p:txBody>
+          <a:bodyPr wrap="square" lIns="0" rIns="0" tIns="0" bIns="0" anchor="t">
+            <a:spAutoFit/>
+          </a:bodyPr>
+          <a:lstStyle/>
+          <a:p>
+            <a:pPr algn="ctr"/>
+            <a:r>
+              <a:rPr sz="1000" b="1" i="0" spc="300">
+                <a:solidFill>
+                  <a:srgbClr val="F7D007"/>
+                </a:solidFill>
+                <a:latin typeface="Helvetica Neue"/>
+              </a:rPr>
+              <a:t>Test 03 · Kasse-PDP</a:t>
+            </a:r>
+          </a:p>
+        </p:txBody>
+      </p:sp>
+      <p:sp>
+        <p:nvSpPr>
+          <p:cNvPr id="8" name="TextBox 7"/>
+          <p:cNvSpPr txBox="1"/>
+          <p:nvPr/>
+        </p:nvSpPr>
+        <p:spPr>
+          <a:xfrm>
+            <a:off x="640080" y="841248"/>
+            <a:ext cx="10911535" cy="640080"/>
+          </a:xfrm>
+          <a:prstGeom prst="rect">
+            <a:avLst/>
+          </a:prstGeom>
+          <a:noFill/>
+        </p:spPr>
+        <p:txBody>
+          <a:bodyPr wrap="square" lIns="0" rIns="0" tIns="0" bIns="0" anchor="t">
+            <a:spAutoFit/>
+          </a:bodyPr>
+          <a:lstStyle/>
+          <a:p>
+            <a:pPr algn="ctr"/>
+            <a:r>
+              <a:rPr sz="3000" b="1" i="0" spc="-50">
+                <a:solidFill>
+                  <a:srgbClr val="FFFFFF"/>
+                </a:solidFill>
+                <a:latin typeface="Helvetica Neue"/>
+              </a:rPr>
+              <a:t>Kasse-PDP: AOV-stige &amp; smag per vin</a:t>
+            </a:r>
+          </a:p>
+        </p:txBody>
+      </p:sp>
+      <p:sp>
+        <p:nvSpPr>
+          <p:cNvPr id="9" name="TextBox 8"/>
+          <p:cNvSpPr txBox="1"/>
+          <p:nvPr/>
+        </p:nvSpPr>
+        <p:spPr>
+          <a:xfrm>
+            <a:off x="1828800" y="1463040"/>
+            <a:ext cx="8534095" cy="548640"/>
+          </a:xfrm>
+          <a:prstGeom prst="rect">
+            <a:avLst/>
+          </a:prstGeom>
+          <a:noFill/>
+        </p:spPr>
+        <p:txBody>
+          <a:bodyPr wrap="square" lIns="0" rIns="0" tIns="0" bIns="0" anchor="t">
+            <a:spAutoFit/>
+          </a:bodyPr>
+          <a:lstStyle/>
+          <a:p>
+            <a:pPr algn="ctr"/>
+            <a:r>
+              <a:rPr sz="1200" b="0" i="0">
+                <a:solidFill>
+                  <a:srgbClr val="999999"/>
+                </a:solidFill>
+                <a:latin typeface="Helvetica Neue"/>
+              </a:rPr>
+              <a:t>Hypotese: en kassestige plus rigtige detaljer per vin løfter ordreværdi og læg i kurv, fordi det fjerner risikoen ved den blinde kasse bag indvendingen "hvordan smager den".</a:t>
+            </a:r>
+          </a:p>
+        </p:txBody>
+      </p:sp>
+      <p:pic>
+        <p:nvPicPr>
+          <p:cNvPr id="10" name="Picture 9" descr="t3-hifi.jpeg"/>
+          <p:cNvPicPr>
+            <a:picLocks noChangeAspect="1"/>
+          </p:cNvPicPr>
+          <p:nvPr/>
+        </p:nvPicPr>
+        <p:blipFill>
+          <a:blip r:embed="rId3"/>
+          <a:stretch>
+            <a:fillRect/>
+          </a:stretch>
+        </p:blipFill>
+        <p:spPr>
+          <a:xfrm>
+            <a:off x="822960" y="1783080"/>
+            <a:ext cx="2070401" cy="4480560"/>
+          </a:xfrm>
+          <a:prstGeom prst="rect">
+            <a:avLst/>
+          </a:prstGeom>
+        </p:spPr>
+      </p:pic>
+      <p:sp>
+        <p:nvSpPr>
+          <p:cNvPr id="11" name="Rounded Rectangle 10"/>
+          <p:cNvSpPr/>
+          <p:nvPr/>
+        </p:nvSpPr>
+        <p:spPr>
+          <a:xfrm>
+            <a:off x="777240" y="1737360"/>
+            <a:ext cx="2161841" cy="4572000"/>
+          </a:xfrm>
+          <a:prstGeom prst="roundRect">
+            <a:avLst>
+              <a:gd name="adj" fmla="val 4000"/>
+            </a:avLst>
+          </a:prstGeom>
+          <a:noFill/>
+          <a:ln w="19050">
+            <a:solidFill>
+              <a:srgbClr val="303030"/>
+            </a:solidFill>
+          </a:ln>
+        </p:spPr>
+        <p:style>
+          <a:lnRef idx="1">
+            <a:schemeClr val="accent1"/>
+          </a:lnRef>
+          <a:fillRef idx="3">
+            <a:schemeClr val="accent1"/>
+          </a:fillRef>
+          <a:effectRef idx="2">
+            <a:schemeClr val="accent1"/>
+          </a:effectRef>
+          <a:fontRef idx="minor">
+            <a:schemeClr val="lt1"/>
+          </a:fontRef>
+        </p:style>
+        <p:txBody>
+          <a:bodyPr rtlCol="0" anchor="ctr"/>
+          <a:lstStyle/>
+          <a:p>
+            <a:pPr algn="ctr"/>
+          </a:p>
+        </p:txBody>
+      </p:sp>
+      <p:sp>
+        <p:nvSpPr>
+          <p:cNvPr id="12" name="TextBox 11"/>
+          <p:cNvSpPr txBox="1"/>
+          <p:nvPr/>
+        </p:nvSpPr>
+        <p:spPr>
+          <a:xfrm>
+            <a:off x="777240" y="6355080"/>
+            <a:ext cx="2253281" cy="274320"/>
+          </a:xfrm>
+          <a:prstGeom prst="rect">
+            <a:avLst/>
+          </a:prstGeom>
+          <a:noFill/>
+        </p:spPr>
+        <p:txBody>
+          <a:bodyPr wrap="square" lIns="0" rIns="0" tIns="0" bIns="0" anchor="t">
+            <a:spAutoFit/>
+          </a:bodyPr>
+          <a:lstStyle/>
+          <a:p>
+            <a:pPr algn="ctr"/>
+            <a:r>
+              <a:rPr sz="900" b="0" i="0" spc="100">
+                <a:solidFill>
+                  <a:srgbClr val="6B7C75"/>
+                </a:solidFill>
+                <a:latin typeface="Helvetica Neue"/>
+              </a:rPr>
+              <a:t>Variant box page, mocked on the live PDP</a:t>
+            </a:r>
+          </a:p>
+        </p:txBody>
+      </p:sp>
+      <p:sp>
+        <p:nvSpPr>
+          <p:cNvPr id="13" name="Oval 12"/>
+          <p:cNvSpPr/>
+          <p:nvPr/>
+        </p:nvSpPr>
+        <p:spPr>
+          <a:xfrm>
+            <a:off x="3350561" y="1874520"/>
+            <a:ext cx="100584" cy="100584"/>
+          </a:xfrm>
+          <a:prstGeom prst="ellipse">
+            <a:avLst/>
+          </a:prstGeom>
+          <a:solidFill>
+            <a:srgbClr val="22C55E"/>
+          </a:solidFill>
+          <a:ln>
+            <a:noFill/>
+          </a:ln>
+        </p:spPr>
+        <p:style>
+          <a:lnRef idx="1">
+            <a:schemeClr val="accent1"/>
+          </a:lnRef>
+          <a:fillRef idx="3">
+            <a:schemeClr val="accent1"/>
+          </a:fillRef>
+          <a:effectRef idx="2">
+            <a:schemeClr val="accent1"/>
+          </a:effectRef>
+          <a:fontRef idx="minor">
+            <a:schemeClr val="lt1"/>
+          </a:fontRef>
+        </p:style>
+        <p:txBody>
+          <a:bodyPr rtlCol="0" anchor="ctr"/>
+          <a:lstStyle/>
+          <a:p>
+            <a:pPr algn="ctr"/>
+          </a:p>
+        </p:txBody>
+      </p:sp>
+      <p:sp>
+        <p:nvSpPr>
+          <p:cNvPr id="14" name="TextBox 13"/>
+          <p:cNvSpPr txBox="1"/>
+          <p:nvPr/>
+        </p:nvSpPr>
+        <p:spPr>
+          <a:xfrm>
+            <a:off x="3624881" y="1828800"/>
+            <a:ext cx="8018174" cy="822960"/>
+          </a:xfrm>
+          <a:prstGeom prst="rect">
+            <a:avLst/>
+          </a:prstGeom>
+          <a:noFill/>
+        </p:spPr>
+        <p:txBody>
+          <a:bodyPr wrap="square" lIns="0" rIns="0" tIns="0" bIns="0" anchor="t">
+            <a:spAutoFit/>
+          </a:bodyPr>
+          <a:lstStyle/>
+          <a:p>
+            <a:pPr algn="l">
+              <a:lnSpc>
+                <a:spcPct val="105000"/>
+              </a:lnSpc>
+            </a:pPr>
+            <a:r>
+              <a:rPr sz="1100" b="1" i="0">
+                <a:solidFill>
+                  <a:srgbClr val="FFFFFF"/>
+                </a:solidFill>
+                <a:latin typeface="Helvetica Neue"/>
+              </a:rPr>
+              <a:t>En kassestige i tre niveauer </a:t>
+            </a:r>
+            <a:r>
+              <a:rPr sz="1100" b="0" i="0">
+                <a:solidFill>
+                  <a:srgbClr val="CCCCCC"/>
+                </a:solidFill>
+                <a:latin typeface="Helvetica Neue"/>
+              </a:rPr>
+              <a:t>(6, 12 XL, 12 Guld) med 12 XL forvalgt som "populärast", der forankrer købere op fra 567 mod niveauerne på 700 SEK plus.</a:t>
+            </a:r>
+          </a:p>
+        </p:txBody>
+      </p:sp>
+      <p:sp>
+        <p:nvSpPr>
+          <p:cNvPr id="15" name="Oval 14"/>
+          <p:cNvSpPr/>
+          <p:nvPr/>
+        </p:nvSpPr>
+        <p:spPr>
+          <a:xfrm>
+            <a:off x="3350561" y="2377440"/>
+            <a:ext cx="100584" cy="100584"/>
+          </a:xfrm>
+          <a:prstGeom prst="ellipse">
+            <a:avLst/>
+          </a:prstGeom>
+          <a:solidFill>
+            <a:srgbClr val="22C55E"/>
+          </a:solidFill>
+          <a:ln>
+            <a:noFill/>
+          </a:ln>
+        </p:spPr>
+        <p:style>
+          <a:lnRef idx="1">
+            <a:schemeClr val="accent1"/>
+          </a:lnRef>
+          <a:fillRef idx="3">
+            <a:schemeClr val="accent1"/>
+          </a:fillRef>
+          <a:effectRef idx="2">
+            <a:schemeClr val="accent1"/>
+          </a:effectRef>
+          <a:fontRef idx="minor">
+            <a:schemeClr val="lt1"/>
+          </a:fontRef>
+        </p:style>
+        <p:txBody>
+          <a:bodyPr rtlCol="0" anchor="ctr"/>
+          <a:lstStyle/>
+          <a:p>
+            <a:pPr algn="ctr"/>
+          </a:p>
+        </p:txBody>
+      </p:sp>
+      <p:sp>
+        <p:nvSpPr>
+          <p:cNvPr id="16" name="TextBox 15"/>
+          <p:cNvSpPr txBox="1"/>
+          <p:nvPr/>
+        </p:nvSpPr>
+        <p:spPr>
+          <a:xfrm>
+            <a:off x="3624881" y="2331720"/>
+            <a:ext cx="8018174" cy="822960"/>
+          </a:xfrm>
+          <a:prstGeom prst="rect">
+            <a:avLst/>
+          </a:prstGeom>
+          <a:noFill/>
+        </p:spPr>
+        <p:txBody>
+          <a:bodyPr wrap="square" lIns="0" rIns="0" tIns="0" bIns="0" anchor="t">
+            <a:spAutoFit/>
+          </a:bodyPr>
+          <a:lstStyle/>
+          <a:p>
+            <a:pPr algn="l">
+              <a:lnSpc>
+                <a:spcPct val="105000"/>
+              </a:lnSpc>
+            </a:pPr>
+            <a:r>
+              <a:rPr sz="1100" b="1" i="0">
+                <a:solidFill>
+                  <a:srgbClr val="FFFFFF"/>
+                </a:solidFill>
+                <a:latin typeface="Helvetica Neue"/>
+              </a:rPr>
+              <a:t>Værdiregnestykke per flaske </a:t>
+            </a:r>
+            <a:r>
+              <a:rPr sz="1100" b="0" i="0">
+                <a:solidFill>
+                  <a:srgbClr val="CCCCCC"/>
+                </a:solidFill>
+                <a:latin typeface="Helvetica Neue"/>
+              </a:rPr>
+              <a:t>(53 kr per flaske på XL) får den større kasse til at fremstå som det smarte køb, ikke det dyre.</a:t>
+            </a:r>
+          </a:p>
+        </p:txBody>
+      </p:sp>
+      <p:sp>
+        <p:nvSpPr>
+          <p:cNvPr id="17" name="Oval 16"/>
+          <p:cNvSpPr/>
+          <p:nvPr/>
+        </p:nvSpPr>
+        <p:spPr>
+          <a:xfrm>
+            <a:off x="3350561" y="2880360"/>
+            <a:ext cx="100584" cy="100584"/>
+          </a:xfrm>
+          <a:prstGeom prst="ellipse">
+            <a:avLst/>
+          </a:prstGeom>
+          <a:solidFill>
+            <a:srgbClr val="22C55E"/>
+          </a:solidFill>
+          <a:ln>
+            <a:noFill/>
+          </a:ln>
+        </p:spPr>
+        <p:style>
+          <a:lnRef idx="1">
+            <a:schemeClr val="accent1"/>
+          </a:lnRef>
+          <a:fillRef idx="3">
+            <a:schemeClr val="accent1"/>
+          </a:fillRef>
+          <a:effectRef idx="2">
+            <a:schemeClr val="accent1"/>
+          </a:effectRef>
+          <a:fontRef idx="minor">
+            <a:schemeClr val="lt1"/>
+          </a:fontRef>
+        </p:style>
+        <p:txBody>
+          <a:bodyPr rtlCol="0" anchor="ctr"/>
+          <a:lstStyle/>
+          <a:p>
+            <a:pPr algn="ctr"/>
+          </a:p>
+        </p:txBody>
+      </p:sp>
+      <p:sp>
+        <p:nvSpPr>
+          <p:cNvPr id="18" name="TextBox 17"/>
+          <p:cNvSpPr txBox="1"/>
+          <p:nvPr/>
+        </p:nvSpPr>
+        <p:spPr>
+          <a:xfrm>
+            <a:off x="3624881" y="2834640"/>
+            <a:ext cx="8018174" cy="822960"/>
+          </a:xfrm>
+          <a:prstGeom prst="rect">
+            <a:avLst/>
+          </a:prstGeom>
+          <a:noFill/>
+        </p:spPr>
+        <p:txBody>
+          <a:bodyPr wrap="square" lIns="0" rIns="0" tIns="0" bIns="0" anchor="t">
+            <a:spAutoFit/>
+          </a:bodyPr>
+          <a:lstStyle/>
+          <a:p>
+            <a:pPr algn="l">
+              <a:lnSpc>
+                <a:spcPct val="105000"/>
+              </a:lnSpc>
+            </a:pPr>
+            <a:r>
+              <a:rPr sz="1100" b="1" i="0">
+                <a:solidFill>
+                  <a:srgbClr val="FFFFFF"/>
+                </a:solidFill>
+                <a:latin typeface="Helvetica Neue"/>
+              </a:rPr>
+              <a:t>"Vad ingår" åbner den blinde kasse, </a:t>
+            </a:r>
+            <a:r>
+              <a:rPr sz="1100" b="0" i="0">
+                <a:solidFill>
+                  <a:srgbClr val="CCCCCC"/>
+                </a:solidFill>
+                <a:latin typeface="Helvetica Neue"/>
+              </a:rPr>
+              <a:t>navngivne vine, region, Vivino-scorer og en skala fra tør til sød, der besvarer smagsindvendingen, før den opstår.</a:t>
+            </a:r>
+          </a:p>
+        </p:txBody>
+      </p:sp>
+    </p:spTree>
+  </p:cSld>
+  <p:clrMapOvr>
+    <a:masterClrMapping/>
+  </p:clrMapOvr>
+</p:sld>
+</file>
+
+<file path=ppt/slides/slide54.xml><?xml version="1.0" encoding="utf-8"?>
+<p:sld xmlns:a="http://schemas.openxmlformats.org/drawingml/2006/main" xmlns:p="http://schemas.openxmlformats.org/presentationml/2006/main" xmlns:r="http://schemas.openxmlformats.org/officeDocument/2006/relationships">
+  <p:cSld>
+    <p:spTree>
+      <p:nvGrpSpPr>
+        <p:cNvPr id="1" name=""/>
+        <p:cNvGrpSpPr/>
+        <p:nvPr/>
+      </p:nvGrpSpPr>
+      <p:grpSpPr/>
+      <p:sp>
+        <p:nvSpPr>
+          <p:cNvPr id="2" name="Rectangle 1"/>
+          <p:cNvSpPr/>
+          <p:nvPr/>
+        </p:nvSpPr>
+        <p:spPr>
+          <a:xfrm>
+            <a:off x="0" y="0"/>
+            <a:ext cx="12191695" cy="6858000"/>
+          </a:xfrm>
+          <a:prstGeom prst="rect">
+            <a:avLst/>
+          </a:prstGeom>
+          <a:solidFill>
+            <a:srgbClr val="000000"/>
+          </a:solidFill>
+          <a:ln>
+            <a:noFill/>
+          </a:ln>
+        </p:spPr>
+        <p:style>
+          <a:lnRef idx="1">
+            <a:schemeClr val="accent1"/>
+          </a:lnRef>
+          <a:fillRef idx="3">
+            <a:schemeClr val="accent1"/>
+          </a:fillRef>
+          <a:effectRef idx="2">
+            <a:schemeClr val="accent1"/>
+          </a:effectRef>
+          <a:fontRef idx="minor">
+            <a:schemeClr val="lt1"/>
+          </a:fontRef>
+        </p:style>
+        <p:txBody>
+          <a:bodyPr rtlCol="0" anchor="ctr"/>
+          <a:lstStyle/>
+          <a:p>
+            <a:pPr algn="ctr"/>
+          </a:p>
+        </p:txBody>
+      </p:sp>
+      <p:pic>
+        <p:nvPicPr>
+          <p:cNvPr id="3" name="Picture 2" descr="ecomhouse-wordmark.png"/>
+          <p:cNvPicPr>
+            <a:picLocks noChangeAspect="1"/>
+          </p:cNvPicPr>
+          <p:nvPr/>
+        </p:nvPicPr>
+        <p:blipFill>
+          <a:blip r:embed="rId2"/>
+          <a:stretch>
+            <a:fillRect/>
+          </a:stretch>
+        </p:blipFill>
+        <p:spPr>
+          <a:xfrm>
+            <a:off x="292608" y="201168"/>
+            <a:ext cx="1873736" cy="201168"/>
+          </a:xfrm>
+          <a:prstGeom prst="rect">
+            <a:avLst/>
+          </a:prstGeom>
+        </p:spPr>
+      </p:pic>
+      <p:sp>
+        <p:nvSpPr>
+          <p:cNvPr id="4" name="TextBox 3"/>
+          <p:cNvSpPr txBox="1"/>
+          <p:nvPr/>
+        </p:nvSpPr>
+        <p:spPr>
+          <a:xfrm>
+            <a:off x="11475720" y="201168"/>
+            <a:ext cx="548640" cy="274320"/>
+          </a:xfrm>
+          <a:prstGeom prst="rect">
+            <a:avLst/>
+          </a:prstGeom>
+          <a:noFill/>
+        </p:spPr>
+        <p:txBody>
+          <a:bodyPr wrap="square" lIns="0" rIns="0" tIns="0" bIns="0" anchor="t">
+            <a:spAutoFit/>
+          </a:bodyPr>
+          <a:lstStyle/>
+          <a:p>
+            <a:pPr algn="r"/>
+            <a:r>
+              <a:rPr sz="1000" b="0" i="0">
+                <a:solidFill>
+                  <a:srgbClr val="EFEEEE"/>
+                </a:solidFill>
+                <a:latin typeface="Helvetica Neue"/>
+              </a:rPr>
+              <a:t>2026</a:t>
+            </a:r>
+          </a:p>
+        </p:txBody>
+      </p:sp>
+      <p:sp>
+        <p:nvSpPr>
+          <p:cNvPr id="5" name="TextBox 4"/>
+          <p:cNvSpPr txBox="1"/>
+          <p:nvPr/>
+        </p:nvSpPr>
+        <p:spPr>
+          <a:xfrm>
+            <a:off x="292608" y="6565392"/>
+            <a:ext cx="4114800" cy="228600"/>
+          </a:xfrm>
+          <a:prstGeom prst="rect">
+            <a:avLst/>
+          </a:prstGeom>
+          <a:noFill/>
+        </p:spPr>
+        <p:txBody>
+          <a:bodyPr wrap="square" lIns="0" rIns="0" tIns="0" bIns="0" anchor="t">
+            <a:spAutoFit/>
+          </a:bodyPr>
+          <a:lstStyle/>
+          <a:p>
+            <a:pPr algn="l"/>
+            <a:r>
+              <a:rPr sz="800" b="0" i="0" spc="150">
+                <a:solidFill>
+                  <a:srgbClr val="EFEEEE"/>
+                </a:solidFill>
+                <a:latin typeface="Helvetica Neue"/>
+              </a:rPr>
+              <a:t>ECOMHOUSE ©ALL RIGHTS RESERVED</a:t>
+            </a:r>
+          </a:p>
+        </p:txBody>
+      </p:sp>
+      <p:sp>
+        <p:nvSpPr>
+          <p:cNvPr id="6" name="TextBox 5"/>
+          <p:cNvSpPr txBox="1"/>
+          <p:nvPr/>
+        </p:nvSpPr>
+        <p:spPr>
+          <a:xfrm>
+            <a:off x="11475720" y="6565392"/>
+            <a:ext cx="548640" cy="228600"/>
+          </a:xfrm>
+          <a:prstGeom prst="rect">
+            <a:avLst/>
+          </a:prstGeom>
+          <a:noFill/>
+        </p:spPr>
+        <p:txBody>
+          <a:bodyPr wrap="square" lIns="0" rIns="0" tIns="0" bIns="0" anchor="t">
+            <a:spAutoFit/>
+          </a:bodyPr>
+          <a:lstStyle/>
+          <a:p>
+            <a:pPr algn="r"/>
+            <a:r>
+              <a:rPr sz="800" b="0" i="0">
+                <a:solidFill>
+                  <a:srgbClr val="EFEEEE"/>
+                </a:solidFill>
+                <a:latin typeface="Menlo"/>
+              </a:rPr>
+              <a:t>53</a:t>
+            </a:r>
+          </a:p>
+        </p:txBody>
+      </p:sp>
+      <p:sp>
+        <p:nvSpPr>
+          <p:cNvPr id="7" name="TextBox 6"/>
+          <p:cNvSpPr txBox="1"/>
+          <p:nvPr/>
+        </p:nvSpPr>
+        <p:spPr>
+          <a:xfrm>
+            <a:off x="0" y="1828800"/>
+            <a:ext cx="12191695" cy="1828800"/>
+          </a:xfrm>
+          <a:prstGeom prst="rect">
+            <a:avLst/>
+          </a:prstGeom>
+          <a:noFill/>
+        </p:spPr>
+        <p:txBody>
+          <a:bodyPr wrap="square" lIns="0" rIns="0" tIns="0" bIns="0" anchor="ctr">
+            <a:spAutoFit/>
+          </a:bodyPr>
+          <a:lstStyle/>
+          <a:p>
+            <a:pPr algn="ctr"/>
+            <a:r>
+              <a:rPr sz="11000" b="0" i="0">
+                <a:solidFill>
+                  <a:srgbClr val="332A02"/>
+                </a:solidFill>
+                <a:latin typeface="Menlo"/>
+              </a:rPr>
+              <a:t>10</a:t>
+            </a:r>
+          </a:p>
+        </p:txBody>
+      </p:sp>
+      <p:sp>
+        <p:nvSpPr>
+          <p:cNvPr id="8" name="TextBox 7"/>
+          <p:cNvSpPr txBox="1"/>
+          <p:nvPr/>
+        </p:nvSpPr>
+        <p:spPr>
+          <a:xfrm>
+            <a:off x="0" y="3291840"/>
+            <a:ext cx="12191695" cy="274320"/>
+          </a:xfrm>
+          <a:prstGeom prst="rect">
+            <a:avLst/>
+          </a:prstGeom>
+          <a:noFill/>
+        </p:spPr>
+        <p:txBody>
+          <a:bodyPr wrap="square" lIns="0" rIns="0" tIns="0" bIns="0" anchor="t">
+            <a:spAutoFit/>
+          </a:bodyPr>
+          <a:lstStyle/>
+          <a:p>
+            <a:pPr algn="ctr"/>
+            <a:r>
+              <a:rPr sz="1100" b="1" i="0" spc="400">
+                <a:solidFill>
+                  <a:srgbClr val="F7D007"/>
+                </a:solidFill>
+                <a:latin typeface="Helvetica Neue"/>
+              </a:rPr>
+              <a:t/>
+            </a:r>
+          </a:p>
+        </p:txBody>
+      </p:sp>
+      <p:sp>
+        <p:nvSpPr>
+          <p:cNvPr id="9" name="TextBox 8"/>
+          <p:cNvSpPr txBox="1"/>
+          <p:nvPr/>
+        </p:nvSpPr>
+        <p:spPr>
+          <a:xfrm>
+            <a:off x="731520" y="3611880"/>
+            <a:ext cx="10728655" cy="822960"/>
+          </a:xfrm>
+          <a:prstGeom prst="rect">
+            <a:avLst/>
+          </a:prstGeom>
+          <a:noFill/>
+        </p:spPr>
+        <p:txBody>
+          <a:bodyPr wrap="square" lIns="0" rIns="0" tIns="0" bIns="0" anchor="t">
+            <a:spAutoFit/>
+          </a:bodyPr>
+          <a:lstStyle/>
+          <a:p>
+            <a:pPr algn="ctr"/>
+            <a:r>
+              <a:rPr sz="4400" b="1" i="0" spc="-100">
+                <a:solidFill>
+                  <a:srgbClr val="FFFFFF"/>
+                </a:solidFill>
+                <a:latin typeface="Helvetica Neue"/>
+              </a:rPr>
+              <a:t>Samarbejde med EcomHouse</a:t>
+            </a:r>
+          </a:p>
+        </p:txBody>
+      </p:sp>
+      <p:sp>
+        <p:nvSpPr>
+          <p:cNvPr id="10" name="TextBox 9"/>
+          <p:cNvSpPr txBox="1"/>
+          <p:nvPr/>
+        </p:nvSpPr>
+        <p:spPr>
+          <a:xfrm>
+            <a:off x="2103120" y="4480560"/>
+            <a:ext cx="7985455" cy="1097280"/>
+          </a:xfrm>
+          <a:prstGeom prst="rect">
+            <a:avLst/>
+          </a:prstGeom>
+          <a:noFill/>
+        </p:spPr>
+        <p:txBody>
+          <a:bodyPr wrap="square" lIns="0" rIns="0" tIns="0" bIns="0" anchor="t">
+            <a:spAutoFit/>
+          </a:bodyPr>
+          <a:lstStyle/>
+          <a:p>
+            <a:pPr algn="ctr"/>
+            <a:r>
+              <a:rPr sz="1300" b="0" i="0">
+                <a:solidFill>
+                  <a:srgbClr val="999999"/>
+                </a:solidFill>
+                <a:latin typeface="Helvetica Neue"/>
+              </a:rPr>
+              <a:t>Sådan tester vi, og sådan afregner vi.</a:t>
+            </a:r>
+          </a:p>
+        </p:txBody>
+      </p:sp>
+    </p:spTree>
+  </p:cSld>
+  <p:clrMapOvr>
+    <a:masterClrMapping/>
+  </p:clrMapOvr>
+</p:sld>
+</file>
+
+<file path=ppt/slides/slide55.xml><?xml version="1.0" encoding="utf-8"?>
+<p:sld xmlns:a="http://schemas.openxmlformats.org/drawingml/2006/main" xmlns:p="http://schemas.openxmlformats.org/presentationml/2006/main" xmlns:r="http://schemas.openxmlformats.org/officeDocument/2006/relationships">
+  <p:cSld>
+    <p:spTree>
+      <p:nvGrpSpPr>
+        <p:cNvPr id="1" name=""/>
+        <p:cNvGrpSpPr/>
+        <p:nvPr/>
+      </p:nvGrpSpPr>
+      <p:grpSpPr/>
+      <p:sp>
+        <p:nvSpPr>
+          <p:cNvPr id="2" name="Rectangle 1"/>
+          <p:cNvSpPr/>
+          <p:nvPr/>
+        </p:nvSpPr>
+        <p:spPr>
+          <a:xfrm>
+            <a:off x="0" y="0"/>
+            <a:ext cx="12191695" cy="6858000"/>
+          </a:xfrm>
+          <a:prstGeom prst="rect">
+            <a:avLst/>
+          </a:prstGeom>
+          <a:solidFill>
+            <a:srgbClr val="000000"/>
+          </a:solidFill>
+          <a:ln>
+            <a:noFill/>
+          </a:ln>
+        </p:spPr>
+        <p:style>
+          <a:lnRef idx="1">
+            <a:schemeClr val="accent1"/>
+          </a:lnRef>
+          <a:fillRef idx="3">
+            <a:schemeClr val="accent1"/>
+          </a:fillRef>
+          <a:effectRef idx="2">
+            <a:schemeClr val="accent1"/>
+          </a:effectRef>
+          <a:fontRef idx="minor">
+            <a:schemeClr val="lt1"/>
+          </a:fontRef>
+        </p:style>
+        <p:txBody>
+          <a:bodyPr rtlCol="0" anchor="ctr"/>
+          <a:lstStyle/>
+          <a:p>
+            <a:pPr algn="ctr"/>
+          </a:p>
+        </p:txBody>
+      </p:sp>
+      <p:pic>
+        <p:nvPicPr>
+          <p:cNvPr id="3" name="Picture 2" descr="ecomhouse-wordmark.png"/>
+          <p:cNvPicPr>
+            <a:picLocks noChangeAspect="1"/>
+          </p:cNvPicPr>
+          <p:nvPr/>
+        </p:nvPicPr>
+        <p:blipFill>
+          <a:blip r:embed="rId2"/>
+          <a:stretch>
+            <a:fillRect/>
+          </a:stretch>
+        </p:blipFill>
+        <p:spPr>
+          <a:xfrm>
+            <a:off x="292608" y="201168"/>
+            <a:ext cx="1873736" cy="201168"/>
+          </a:xfrm>
+          <a:prstGeom prst="rect">
+            <a:avLst/>
+          </a:prstGeom>
+        </p:spPr>
+      </p:pic>
+      <p:sp>
+        <p:nvSpPr>
+          <p:cNvPr id="4" name="TextBox 3"/>
+          <p:cNvSpPr txBox="1"/>
+          <p:nvPr/>
+        </p:nvSpPr>
+        <p:spPr>
+          <a:xfrm>
+            <a:off x="11475720" y="201168"/>
+            <a:ext cx="548640" cy="274320"/>
+          </a:xfrm>
+          <a:prstGeom prst="rect">
+            <a:avLst/>
+          </a:prstGeom>
+          <a:noFill/>
+        </p:spPr>
+        <p:txBody>
+          <a:bodyPr wrap="square" lIns="0" rIns="0" tIns="0" bIns="0" anchor="t">
+            <a:spAutoFit/>
+          </a:bodyPr>
+          <a:lstStyle/>
+          <a:p>
+            <a:pPr algn="r"/>
+            <a:r>
+              <a:rPr sz="1000" b="0" i="0">
+                <a:solidFill>
+                  <a:srgbClr val="EFEEEE"/>
+                </a:solidFill>
+                <a:latin typeface="Helvetica Neue"/>
+              </a:rPr>
+              <a:t>2026</a:t>
+            </a:r>
+          </a:p>
+        </p:txBody>
+      </p:sp>
+      <p:sp>
+        <p:nvSpPr>
+          <p:cNvPr id="5" name="TextBox 4"/>
+          <p:cNvSpPr txBox="1"/>
+          <p:nvPr/>
+        </p:nvSpPr>
+        <p:spPr>
+          <a:xfrm>
+            <a:off x="292608" y="6565392"/>
+            <a:ext cx="4114800" cy="228600"/>
+          </a:xfrm>
+          <a:prstGeom prst="rect">
+            <a:avLst/>
+          </a:prstGeom>
+          <a:noFill/>
+        </p:spPr>
+        <p:txBody>
+          <a:bodyPr wrap="square" lIns="0" rIns="0" tIns="0" bIns="0" anchor="t">
+            <a:spAutoFit/>
+          </a:bodyPr>
+          <a:lstStyle/>
+          <a:p>
+            <a:pPr algn="l"/>
+            <a:r>
+              <a:rPr sz="800" b="0" i="0" spc="150">
+                <a:solidFill>
+                  <a:srgbClr val="EFEEEE"/>
+                </a:solidFill>
+                <a:latin typeface="Helvetica Neue"/>
+              </a:rPr>
+              <a:t>ECOMHOUSE ©ALL RIGHTS RESERVED</a:t>
+            </a:r>
+          </a:p>
+        </p:txBody>
+      </p:sp>
+      <p:sp>
+        <p:nvSpPr>
+          <p:cNvPr id="6" name="TextBox 5"/>
+          <p:cNvSpPr txBox="1"/>
+          <p:nvPr/>
+        </p:nvSpPr>
+        <p:spPr>
+          <a:xfrm>
+            <a:off x="11475720" y="6565392"/>
+            <a:ext cx="548640" cy="228600"/>
+          </a:xfrm>
+          <a:prstGeom prst="rect">
+            <a:avLst/>
+          </a:prstGeom>
+          <a:noFill/>
+        </p:spPr>
+        <p:txBody>
+          <a:bodyPr wrap="square" lIns="0" rIns="0" tIns="0" bIns="0" anchor="t">
+            <a:spAutoFit/>
+          </a:bodyPr>
+          <a:lstStyle/>
+          <a:p>
+            <a:pPr algn="r"/>
+            <a:r>
+              <a:rPr sz="800" b="0" i="0">
+                <a:solidFill>
+                  <a:srgbClr val="EFEEEE"/>
+                </a:solidFill>
+                <a:latin typeface="Menlo"/>
+              </a:rPr>
+              <a:t>54</a:t>
+            </a:r>
+          </a:p>
+        </p:txBody>
+      </p:sp>
+      <p:sp>
+        <p:nvSpPr>
+          <p:cNvPr id="7" name="TextBox 6"/>
+          <p:cNvSpPr txBox="1"/>
+          <p:nvPr/>
+        </p:nvSpPr>
+        <p:spPr>
+          <a:xfrm>
+            <a:off x="640080" y="566928"/>
+            <a:ext cx="10911535" cy="228600"/>
+          </a:xfrm>
+          <a:prstGeom prst="rect">
+            <a:avLst/>
+          </a:prstGeom>
+          <a:noFill/>
+        </p:spPr>
+        <p:txBody>
+          <a:bodyPr wrap="square" lIns="0" rIns="0" tIns="0" bIns="0" anchor="t">
+            <a:spAutoFit/>
+          </a:bodyPr>
+          <a:lstStyle/>
+          <a:p>
+            <a:pPr algn="ctr"/>
+            <a:r>
+              <a:rPr sz="1000" b="1" i="0" spc="300">
+                <a:solidFill>
+                  <a:srgbClr val="F7D007"/>
+                </a:solidFill>
+                <a:latin typeface="Helvetica Neue"/>
+              </a:rPr>
+              <a:t>Samarbejde med EcomHouse · Metode</a:t>
+            </a:r>
+          </a:p>
+        </p:txBody>
+      </p:sp>
+      <p:sp>
+        <p:nvSpPr>
+          <p:cNvPr id="8" name="TextBox 7"/>
+          <p:cNvSpPr txBox="1"/>
+          <p:nvPr/>
+        </p:nvSpPr>
+        <p:spPr>
+          <a:xfrm>
+            <a:off x="640080" y="841248"/>
+            <a:ext cx="10911535" cy="640080"/>
+          </a:xfrm>
+          <a:prstGeom prst="rect">
+            <a:avLst/>
+          </a:prstGeom>
+          <a:noFill/>
+        </p:spPr>
+        <p:txBody>
+          <a:bodyPr wrap="square" lIns="0" rIns="0" tIns="0" bIns="0" anchor="t">
+            <a:spAutoFit/>
+          </a:bodyPr>
+          <a:lstStyle/>
+          <a:p>
+            <a:pPr algn="ctr"/>
+            <a:r>
+              <a:rPr sz="3000" b="1" i="0" spc="-50">
+                <a:solidFill>
+                  <a:srgbClr val="FFFFFF"/>
+                </a:solidFill>
+                <a:latin typeface="Helvetica Neue"/>
+              </a:rPr>
+              <a:t>Sådan arbejder vi: seks trin, hele vejen</a:t>
+            </a:r>
+          </a:p>
+        </p:txBody>
+      </p:sp>
+      <p:sp>
+        <p:nvSpPr>
+          <p:cNvPr id="9" name="TextBox 8"/>
+          <p:cNvSpPr txBox="1"/>
+          <p:nvPr/>
+        </p:nvSpPr>
+        <p:spPr>
+          <a:xfrm>
+            <a:off x="1828800" y="1463040"/>
+            <a:ext cx="8534095" cy="548640"/>
+          </a:xfrm>
+          <a:prstGeom prst="rect">
+            <a:avLst/>
+          </a:prstGeom>
+          <a:noFill/>
+        </p:spPr>
+        <p:txBody>
+          <a:bodyPr wrap="square" lIns="0" rIns="0" tIns="0" bIns="0" anchor="t">
+            <a:spAutoFit/>
+          </a:bodyPr>
+          <a:lstStyle/>
+          <a:p>
+            <a:pPr algn="ctr"/>
+            <a:r>
+              <a:rPr sz="1200" b="0" i="0">
+                <a:solidFill>
+                  <a:srgbClr val="999999"/>
+                </a:solidFill>
+                <a:latin typeface="Helvetica Neue"/>
+              </a:rPr>
+              <a:t>En service uden arbejde for dig. Du godkender, vi udfører. Hvert trin ejes af os, fra research over udvikling, QA og udrulning. Din eneste påkrævede handling er skriftlig godkendelse ved brief- og udrulningsstadierne.</a:t>
+            </a:r>
+          </a:p>
+        </p:txBody>
+      </p:sp>
+      <p:graphicFrame>
+        <p:nvGraphicFramePr>
+          <p:cNvPr id="10" name="Table 9"/>
+          <p:cNvGraphicFramePr>
+            <a:graphicFrameLocks noGrp="1"/>
+          </p:cNvGraphicFramePr>
+          <p:nvPr/>
+        </p:nvGraphicFramePr>
+        <p:xfrm>
+          <a:off x="883767" y="2286000"/>
+          <a:ext cx="10424160" cy="2560320"/>
+        </p:xfrm>
+        <a:graphic>
+          <a:graphicData uri="http://schemas.openxmlformats.org/drawingml/2006/table">
+            <a:tbl>
+              <a:tblPr>
+                <a:tableStyleId>{2D5ABB26-0587-4C30-8999-92F81FD0307C}</a:tableStyleId>
+              </a:tblPr>
+              <a:tblGrid>
+                <a:gridCol w="2084832"/>
+                <a:gridCol w="4169664"/>
+                <a:gridCol w="4169664"/>
+              </a:tblGrid>
+              <a:tr h="365760">
+                <a:tc>
+                  <a:txBody>
+                    <a:bodyPr wrap="square"/>
+                    <a:lstStyle/>
+                    <a:p>
+                      <a:pPr algn="l"/>
+                      <a:r>
+                        <a:rPr sz="900" b="1" spc="100">
+                          <a:solidFill>
+                            <a:srgbClr val="999999"/>
+                          </a:solidFill>
+                          <a:latin typeface="Helvetica Neue"/>
+                        </a:rPr>
+                        <a:t>#</a:t>
+                      </a:r>
+                    </a:p>
+                  </a:txBody>
+                  <a:tcPr marL="73152" marR="73152" marT="18288" marB="18288" anchor="ctr">
+                    <a:solidFill>
+                      <a:srgbClr val="0A0A0A"/>
+                    </a:solidFill>
+                  </a:tcPr>
+                </a:tc>
+                <a:tc>
+                  <a:txBody>
+                    <a:bodyPr wrap="square"/>
+                    <a:lstStyle/>
+                    <a:p>
+                      <a:pPr algn="l"/>
+                      <a:r>
+                        <a:rPr sz="900" b="1" spc="100">
+                          <a:solidFill>
+                            <a:srgbClr val="999999"/>
+                          </a:solidFill>
+                          <a:latin typeface="Helvetica Neue"/>
+                        </a:rPr>
+                        <a:t>TRIN</a:t>
+                      </a:r>
+                    </a:p>
+                  </a:txBody>
+                  <a:tcPr marL="73152" marR="73152" marT="18288" marB="18288" anchor="ctr">
+                    <a:solidFill>
+                      <a:srgbClr val="0A0A0A"/>
+                    </a:solidFill>
+                  </a:tcPr>
+                </a:tc>
+                <a:tc>
+                  <a:txBody>
+                    <a:bodyPr wrap="square"/>
+                    <a:lstStyle/>
+                    <a:p>
+                      <a:pPr algn="l"/>
+                      <a:r>
+                        <a:rPr sz="900" b="1" spc="100">
+                          <a:solidFill>
+                            <a:srgbClr val="999999"/>
+                          </a:solidFill>
+                          <a:latin typeface="Helvetica Neue"/>
+                        </a:rPr>
+                        <a:t>HVAD VI GØR</a:t>
+                      </a:r>
+                    </a:p>
+                  </a:txBody>
+                  <a:tcPr marL="73152" marR="73152" marT="18288" marB="18288" anchor="ctr">
+                    <a:solidFill>
+                      <a:srgbClr val="0A0A0A"/>
+                    </a:solidFill>
+                  </a:tcPr>
+                </a:tc>
+              </a:tr>
+              <a:tr h="365760">
+                <a:tc>
+                  <a:txBody>
+                    <a:bodyPr wrap="square"/>
+                    <a:lstStyle/>
+                    <a:p>
+                      <a:pPr algn="l"/>
+                      <a:r>
+                        <a:rPr sz="1100" b="1">
+                          <a:solidFill>
+                            <a:srgbClr val="F7D007"/>
+                          </a:solidFill>
+                          <a:latin typeface="Helvetica Neue"/>
+                        </a:rPr>
+                        <a:t>01</a:t>
+                      </a:r>
+                    </a:p>
+                  </a:txBody>
+                  <a:tcPr marL="73152" marR="73152" marT="18288" marB="18288" anchor="ctr">
+                    <a:solidFill>
+                      <a:srgbClr val="000000"/>
+                    </a:solidFill>
+                  </a:tcPr>
+                </a:tc>
+                <a:tc>
+                  <a:txBody>
+                    <a:bodyPr wrap="square"/>
+                    <a:lstStyle/>
+                    <a:p>
+                      <a:pPr algn="l"/>
+                      <a:r>
+                        <a:rPr sz="1100" b="0">
+                          <a:solidFill>
+                            <a:srgbClr val="F7D007"/>
+                          </a:solidFill>
+                          <a:latin typeface="Helvetica Neue"/>
+                        </a:rPr>
+                        <a:t>Research</a:t>
+                      </a:r>
+                    </a:p>
+                  </a:txBody>
+                  <a:tcPr marL="73152" marR="73152" marT="18288" marB="18288" anchor="ctr">
+                    <a:solidFill>
+                      <a:srgbClr val="000000"/>
+                    </a:solidFill>
+                  </a:tcPr>
+                </a:tc>
+                <a:tc>
+                  <a:txBody>
+                    <a:bodyPr wrap="square"/>
+                    <a:lstStyle/>
+                    <a:p>
+                      <a:pPr algn="l"/>
+                      <a:r>
+                        <a:rPr sz="1100" b="0">
+                          <a:solidFill>
+                            <a:srgbClr val="EFEEEE"/>
+                          </a:solidFill>
+                          <a:latin typeface="Helvetica Neue"/>
+                        </a:rPr>
+                        <a:t>GA4, Shopify, heatmaps, sessionsoptagelser, anmeldelser og supporttickets.</a:t>
+                      </a:r>
+                    </a:p>
+                  </a:txBody>
+                  <a:tcPr marL="73152" marR="73152" marT="18288" marB="18288" anchor="ctr">
+                    <a:solidFill>
+                      <a:srgbClr val="000000"/>
+                    </a:solidFill>
+                  </a:tcPr>
+                </a:tc>
+              </a:tr>
+              <a:tr h="365760">
+                <a:tc>
+                  <a:txBody>
+                    <a:bodyPr wrap="square"/>
+                    <a:lstStyle/>
+                    <a:p>
+                      <a:pPr algn="l"/>
+                      <a:r>
+                        <a:rPr sz="1100" b="1">
+                          <a:solidFill>
+                            <a:srgbClr val="F7D007"/>
+                          </a:solidFill>
+                          <a:latin typeface="Helvetica Neue"/>
+                        </a:rPr>
+                        <a:t>02</a:t>
+                      </a:r>
+                    </a:p>
+                  </a:txBody>
+                  <a:tcPr marL="73152" marR="73152" marT="18288" marB="18288" anchor="ctr">
+                    <a:solidFill>
+                      <a:srgbClr val="0B0B0B"/>
+                    </a:solidFill>
+                  </a:tcPr>
+                </a:tc>
+                <a:tc>
+                  <a:txBody>
+                    <a:bodyPr wrap="square"/>
+                    <a:lstStyle/>
+                    <a:p>
+                      <a:pPr algn="l"/>
+                      <a:r>
+                        <a:rPr sz="1100" b="0">
+                          <a:solidFill>
+                            <a:srgbClr val="F7D007"/>
+                          </a:solidFill>
+                          <a:latin typeface="Helvetica Neue"/>
+                        </a:rPr>
+                        <a:t>Idéudvikling</a:t>
+                      </a:r>
+                    </a:p>
+                  </a:txBody>
+                  <a:tcPr marL="73152" marR="73152" marT="18288" marB="18288" anchor="ctr">
+                    <a:solidFill>
+                      <a:srgbClr val="0B0B0B"/>
+                    </a:solidFill>
+                  </a:tcPr>
+                </a:tc>
+                <a:tc>
+                  <a:txBody>
+                    <a:bodyPr wrap="square"/>
+                    <a:lstStyle/>
+                    <a:p>
+                      <a:pPr algn="l"/>
+                      <a:r>
+                        <a:rPr sz="1100" b="0">
+                          <a:solidFill>
+                            <a:srgbClr val="EFEEEE"/>
+                          </a:solidFill>
+                          <a:latin typeface="Helvetica Neue"/>
+                        </a:rPr>
+                        <a:t>Hypotese, variantkoncepter, copy og en Figma-prototype.</a:t>
+                      </a:r>
+                    </a:p>
+                  </a:txBody>
+                  <a:tcPr marL="73152" marR="73152" marT="18288" marB="18288" anchor="ctr">
+                    <a:solidFill>
+                      <a:srgbClr val="0B0B0B"/>
+                    </a:solidFill>
+                  </a:tcPr>
+                </a:tc>
+              </a:tr>
+              <a:tr h="365760">
+                <a:tc>
+                  <a:txBody>
+                    <a:bodyPr wrap="square"/>
+                    <a:lstStyle/>
+                    <a:p>
+                      <a:pPr algn="l"/>
+                      <a:r>
+                        <a:rPr sz="1100" b="1">
+                          <a:solidFill>
+                            <a:srgbClr val="F7D007"/>
+                          </a:solidFill>
+                          <a:latin typeface="Helvetica Neue"/>
+                        </a:rPr>
+                        <a:t>03</a:t>
+                      </a:r>
+                    </a:p>
+                  </a:txBody>
+                  <a:tcPr marL="73152" marR="73152" marT="18288" marB="18288" anchor="ctr">
+                    <a:solidFill>
+                      <a:srgbClr val="000000"/>
+                    </a:solidFill>
+                  </a:tcPr>
+                </a:tc>
+                <a:tc>
+                  <a:txBody>
+                    <a:bodyPr wrap="square"/>
+                    <a:lstStyle/>
+                    <a:p>
+                      <a:pPr algn="l"/>
+                      <a:r>
+                        <a:rPr sz="1100" b="0">
+                          <a:solidFill>
+                            <a:srgbClr val="F7D007"/>
+                          </a:solidFill>
+                          <a:latin typeface="Helvetica Neue"/>
+                        </a:rPr>
+                        <a:t>Brief og godkend</a:t>
+                      </a:r>
+                    </a:p>
+                  </a:txBody>
+                  <a:tcPr marL="73152" marR="73152" marT="18288" marB="18288" anchor="ctr">
+                    <a:solidFill>
+                      <a:srgbClr val="000000"/>
+                    </a:solidFill>
+                  </a:tcPr>
+                </a:tc>
+                <a:tc>
+                  <a:txBody>
+                    <a:bodyPr wrap="square"/>
+                    <a:lstStyle/>
+                    <a:p>
+                      <a:pPr algn="l"/>
+                      <a:r>
+                        <a:rPr sz="1100" b="0">
+                          <a:solidFill>
+                            <a:srgbClr val="EFEEEE"/>
+                          </a:solidFill>
+                          <a:latin typeface="Helvetica Neue"/>
+                        </a:rPr>
+                        <a:t>En skriftlig brief med den primære metrik, konfidens, stikprøvestørrelse og stadiemultiplikator. Du godkender før lancering.</a:t>
+                      </a:r>
+                    </a:p>
+                  </a:txBody>
+                  <a:tcPr marL="73152" marR="73152" marT="18288" marB="18288" anchor="ctr">
+                    <a:solidFill>
+                      <a:srgbClr val="000000"/>
+                    </a:solidFill>
+                  </a:tcPr>
+                </a:tc>
+              </a:tr>
+              <a:tr h="365760">
+                <a:tc>
+                  <a:txBody>
+                    <a:bodyPr wrap="square"/>
+                    <a:lstStyle/>
+                    <a:p>
+                      <a:pPr algn="l"/>
+                      <a:r>
+                        <a:rPr sz="1100" b="1">
+                          <a:solidFill>
+                            <a:srgbClr val="F7D007"/>
+                          </a:solidFill>
+                          <a:latin typeface="Helvetica Neue"/>
+                        </a:rPr>
+                        <a:t>04</a:t>
+                      </a:r>
+                    </a:p>
+                  </a:txBody>
+                  <a:tcPr marL="73152" marR="73152" marT="18288" marB="18288" anchor="ctr">
+                    <a:solidFill>
+                      <a:srgbClr val="0B0B0B"/>
+                    </a:solidFill>
+                  </a:tcPr>
+                </a:tc>
+                <a:tc>
+                  <a:txBody>
+                    <a:bodyPr wrap="square"/>
+                    <a:lstStyle/>
+                    <a:p>
+                      <a:pPr algn="l"/>
+                      <a:r>
+                        <a:rPr sz="1100" b="0">
+                          <a:solidFill>
+                            <a:srgbClr val="F7D007"/>
+                          </a:solidFill>
+                          <a:latin typeface="Helvetica Neue"/>
+                        </a:rPr>
+                        <a:t>Byg og QA</a:t>
+                      </a:r>
+                    </a:p>
+                  </a:txBody>
+                  <a:tcPr marL="73152" marR="73152" marT="18288" marB="18288" anchor="ctr">
+                    <a:solidFill>
+                      <a:srgbClr val="0B0B0B"/>
+                    </a:solidFill>
+                  </a:tcPr>
+                </a:tc>
+                <a:tc>
+                  <a:txBody>
+                    <a:bodyPr wrap="square"/>
+                    <a:lstStyle/>
+                    <a:p>
+                      <a:pPr algn="l"/>
+                      <a:r>
+                        <a:rPr sz="1100" b="0">
+                          <a:solidFill>
+                            <a:srgbClr val="EFEEEE"/>
+                          </a:solidFill>
+                          <a:latin typeface="Helvetica Neue"/>
+                        </a:rPr>
+                        <a:t>Shopify- eller testværktøjsvariant, sporet og QA'et på tværs af enheder.</a:t>
+                      </a:r>
+                    </a:p>
+                  </a:txBody>
+                  <a:tcPr marL="73152" marR="73152" marT="18288" marB="18288" anchor="ctr">
+                    <a:solidFill>
+                      <a:srgbClr val="0B0B0B"/>
+                    </a:solidFill>
+                  </a:tcPr>
+                </a:tc>
+              </a:tr>
+              <a:tr h="365760">
+                <a:tc>
+                  <a:txBody>
+                    <a:bodyPr wrap="square"/>
+                    <a:lstStyle/>
+                    <a:p>
+                      <a:pPr algn="l"/>
+                      <a:r>
+                        <a:rPr sz="1100" b="1">
+                          <a:solidFill>
+                            <a:srgbClr val="F7D007"/>
+                          </a:solidFill>
+                          <a:latin typeface="Helvetica Neue"/>
+                        </a:rPr>
+                        <a:t>05</a:t>
+                      </a:r>
+                    </a:p>
+                  </a:txBody>
+                  <a:tcPr marL="73152" marR="73152" marT="18288" marB="18288" anchor="ctr">
+                    <a:solidFill>
+                      <a:srgbClr val="000000"/>
+                    </a:solidFill>
+                  </a:tcPr>
+                </a:tc>
+                <a:tc>
+                  <a:txBody>
+                    <a:bodyPr wrap="square"/>
+                    <a:lstStyle/>
+                    <a:p>
+                      <a:pPr algn="l"/>
+                      <a:r>
+                        <a:rPr sz="1100" b="0">
+                          <a:solidFill>
+                            <a:srgbClr val="F7D007"/>
+                          </a:solidFill>
+                          <a:latin typeface="Helvetica Neue"/>
+                        </a:rPr>
+                        <a:t>Kør og overvåg</a:t>
+                      </a:r>
+                    </a:p>
+                  </a:txBody>
+                  <a:tcPr marL="73152" marR="73152" marT="18288" marB="18288" anchor="ctr">
+                    <a:solidFill>
+                      <a:srgbClr val="000000"/>
+                    </a:solidFill>
+                  </a:tcPr>
+                </a:tc>
+                <a:tc>
+                  <a:txBody>
+                    <a:bodyPr wrap="square"/>
+                    <a:lstStyle/>
+                    <a:p>
+                      <a:pPr algn="l"/>
+                      <a:r>
+                        <a:rPr sz="1100" b="0">
+                          <a:solidFill>
+                            <a:srgbClr val="EFEEEE"/>
+                          </a:solidFill>
+                          <a:latin typeface="Helvetica Neue"/>
+                        </a:rPr>
+                        <a:t>Live test med guardrail-overvågning og ugentlige statusopdateringer.</a:t>
+                      </a:r>
+                    </a:p>
+                  </a:txBody>
+                  <a:tcPr marL="73152" marR="73152" marT="18288" marB="18288" anchor="ctr">
+                    <a:solidFill>
+                      <a:srgbClr val="000000"/>
+                    </a:solidFill>
+                  </a:tcPr>
+                </a:tc>
+              </a:tr>
+              <a:tr h="365760">
+                <a:tc>
+                  <a:txBody>
+                    <a:bodyPr wrap="square"/>
+                    <a:lstStyle/>
+                    <a:p>
+                      <a:pPr algn="l"/>
+                      <a:r>
+                        <a:rPr sz="1100" b="1">
+                          <a:solidFill>
+                            <a:srgbClr val="F7D007"/>
+                          </a:solidFill>
+                          <a:latin typeface="Helvetica Neue"/>
+                        </a:rPr>
+                        <a:t>06</a:t>
+                      </a:r>
+                    </a:p>
+                  </a:txBody>
+                  <a:tcPr marL="73152" marR="73152" marT="18288" marB="18288" anchor="ctr">
+                    <a:solidFill>
+                      <a:srgbClr val="0B0B0B"/>
+                    </a:solidFill>
+                  </a:tcPr>
+                </a:tc>
+                <a:tc>
+                  <a:txBody>
+                    <a:bodyPr wrap="square"/>
+                    <a:lstStyle/>
+                    <a:p>
+                      <a:pPr algn="l"/>
+                      <a:r>
+                        <a:rPr sz="1100" b="0">
+                          <a:solidFill>
+                            <a:srgbClr val="F7D007"/>
+                          </a:solidFill>
+                          <a:latin typeface="Helvetica Neue"/>
+                        </a:rPr>
+                        <a:t>Analysér og rul ud</a:t>
+                      </a:r>
+                    </a:p>
+                  </a:txBody>
+                  <a:tcPr marL="73152" marR="73152" marT="18288" marB="18288" anchor="ctr">
+                    <a:solidFill>
+                      <a:srgbClr val="0B0B0B"/>
+                    </a:solidFill>
+                  </a:tcPr>
+                </a:tc>
+                <a:tc>
+                  <a:txBody>
+                    <a:bodyPr wrap="square"/>
+                    <a:lstStyle/>
+                    <a:p>
+                      <a:pPr algn="l"/>
+                      <a:r>
+                        <a:rPr sz="1100" b="0">
+                          <a:solidFill>
+                            <a:srgbClr val="EFEEEE"/>
+                          </a:solidFill>
+                          <a:latin typeface="Helvetica Neue"/>
+                        </a:rPr>
+                        <a:t>En skriftlig dom, og vindere rulles ud til 100% af trafikken.</a:t>
+                      </a:r>
+                    </a:p>
+                  </a:txBody>
+                  <a:tcPr marL="73152" marR="73152" marT="18288" marB="18288" anchor="ctr">
+                    <a:solidFill>
+                      <a:srgbClr val="0B0B0B"/>
+                    </a:solidFill>
+                  </a:tcPr>
+                </a:tc>
+              </a:tr>
+            </a:tbl>
+          </a:graphicData>
+        </a:graphic>
+      </p:graphicFrame>
+      <p:sp>
+        <p:nvSpPr>
+          <p:cNvPr id="11" name="TextBox 10"/>
+          <p:cNvSpPr txBox="1"/>
+          <p:nvPr/>
+        </p:nvSpPr>
+        <p:spPr>
+          <a:xfrm>
+            <a:off x="822960" y="6053328"/>
+            <a:ext cx="10545775" cy="731520"/>
+          </a:xfrm>
+          <a:prstGeom prst="rect">
+            <a:avLst/>
+          </a:prstGeom>
+          <a:noFill/>
+        </p:spPr>
+        <p:txBody>
+          <a:bodyPr wrap="square" lIns="0" rIns="0" tIns="0" bIns="0" anchor="t">
+            <a:spAutoFit/>
+          </a:bodyPr>
+          <a:lstStyle/>
+          <a:p>
+            <a:pPr algn="ctr"/>
+            <a:r>
+              <a:rPr sz="800" b="0" i="0">
+                <a:solidFill>
+                  <a:srgbClr val="6B7C75"/>
+                </a:solidFill>
+                <a:latin typeface="Helvetica Neue"/>
+              </a:rPr>
+              <a:t>Service uden arbejde for dig: du forventes ikke at udføre produktionsarbejde. Den samme metode skabte de RPV-gevinster, der blev vist tidligere i denne præsentation (se "RPV-sejre vi har leveret"): tillid, sticky læg i kurv og mængdetilbud, hver især kørt til statistisk signifikans.</a:t>
+            </a:r>
+          </a:p>
+        </p:txBody>
+      </p:sp>
+    </p:spTree>
+  </p:cSld>
+  <p:clrMapOvr>
+    <a:masterClrMapping/>
+  </p:clrMapOvr>
+</p:sld>
+</file>
+
+<file path=ppt/slides/slide56.xml><?xml version="1.0" encoding="utf-8"?>
+<p:sld xmlns:a="http://schemas.openxmlformats.org/drawingml/2006/main" xmlns:p="http://schemas.openxmlformats.org/presentationml/2006/main" xmlns:r="http://schemas.openxmlformats.org/officeDocument/2006/relationships">
+  <p:cSld>
+    <p:spTree>
+      <p:nvGrpSpPr>
+        <p:cNvPr id="1" name=""/>
+        <p:cNvGrpSpPr/>
+        <p:nvPr/>
+      </p:nvGrpSpPr>
+      <p:grpSpPr/>
+      <p:sp>
+        <p:nvSpPr>
+          <p:cNvPr id="2" name="Rectangle 1"/>
+          <p:cNvSpPr/>
+          <p:nvPr/>
+        </p:nvSpPr>
+        <p:spPr>
+          <a:xfrm>
+            <a:off x="0" y="0"/>
+            <a:ext cx="12191695" cy="6858000"/>
+          </a:xfrm>
+          <a:prstGeom prst="rect">
+            <a:avLst/>
+          </a:prstGeom>
+          <a:solidFill>
+            <a:srgbClr val="000000"/>
+          </a:solidFill>
+          <a:ln>
+            <a:noFill/>
+          </a:ln>
+        </p:spPr>
+        <p:style>
+          <a:lnRef idx="1">
+            <a:schemeClr val="accent1"/>
+          </a:lnRef>
+          <a:fillRef idx="3">
+            <a:schemeClr val="accent1"/>
+          </a:fillRef>
+          <a:effectRef idx="2">
+            <a:schemeClr val="accent1"/>
+          </a:effectRef>
+          <a:fontRef idx="minor">
+            <a:schemeClr val="lt1"/>
+          </a:fontRef>
+        </p:style>
+        <p:txBody>
+          <a:bodyPr rtlCol="0" anchor="ctr"/>
+          <a:lstStyle/>
+          <a:p>
+            <a:pPr algn="ctr"/>
+          </a:p>
+        </p:txBody>
+      </p:sp>
+      <p:pic>
+        <p:nvPicPr>
+          <p:cNvPr id="3" name="Picture 2" descr="ecomhouse-wordmark.png"/>
+          <p:cNvPicPr>
+            <a:picLocks noChangeAspect="1"/>
+          </p:cNvPicPr>
+          <p:nvPr/>
+        </p:nvPicPr>
+        <p:blipFill>
+          <a:blip r:embed="rId2"/>
+          <a:stretch>
+            <a:fillRect/>
+          </a:stretch>
+        </p:blipFill>
+        <p:spPr>
+          <a:xfrm>
+            <a:off x="292608" y="201168"/>
+            <a:ext cx="1873736" cy="201168"/>
+          </a:xfrm>
+          <a:prstGeom prst="rect">
+            <a:avLst/>
+          </a:prstGeom>
+        </p:spPr>
+      </p:pic>
+      <p:sp>
+        <p:nvSpPr>
+          <p:cNvPr id="4" name="TextBox 3"/>
+          <p:cNvSpPr txBox="1"/>
+          <p:nvPr/>
+        </p:nvSpPr>
+        <p:spPr>
+          <a:xfrm>
+            <a:off x="11475720" y="201168"/>
+            <a:ext cx="548640" cy="274320"/>
+          </a:xfrm>
+          <a:prstGeom prst="rect">
+            <a:avLst/>
+          </a:prstGeom>
+          <a:noFill/>
+        </p:spPr>
+        <p:txBody>
+          <a:bodyPr wrap="square" lIns="0" rIns="0" tIns="0" bIns="0" anchor="t">
+            <a:spAutoFit/>
+          </a:bodyPr>
+          <a:lstStyle/>
+          <a:p>
+            <a:pPr algn="r"/>
+            <a:r>
+              <a:rPr sz="1000" b="0" i="0">
+                <a:solidFill>
+                  <a:srgbClr val="EFEEEE"/>
+                </a:solidFill>
+                <a:latin typeface="Helvetica Neue"/>
+              </a:rPr>
+              <a:t>2026</a:t>
+            </a:r>
+          </a:p>
+        </p:txBody>
+      </p:sp>
+      <p:sp>
+        <p:nvSpPr>
+          <p:cNvPr id="5" name="TextBox 4"/>
+          <p:cNvSpPr txBox="1"/>
+          <p:nvPr/>
+        </p:nvSpPr>
+        <p:spPr>
+          <a:xfrm>
+            <a:off x="292608" y="6565392"/>
+            <a:ext cx="4114800" cy="228600"/>
+          </a:xfrm>
+          <a:prstGeom prst="rect">
+            <a:avLst/>
+          </a:prstGeom>
+          <a:noFill/>
+        </p:spPr>
+        <p:txBody>
+          <a:bodyPr wrap="square" lIns="0" rIns="0" tIns="0" bIns="0" anchor="t">
+            <a:spAutoFit/>
+          </a:bodyPr>
+          <a:lstStyle/>
+          <a:p>
+            <a:pPr algn="l"/>
+            <a:r>
+              <a:rPr sz="800" b="0" i="0" spc="150">
+                <a:solidFill>
+                  <a:srgbClr val="EFEEEE"/>
+                </a:solidFill>
+                <a:latin typeface="Helvetica Neue"/>
+              </a:rPr>
+              <a:t>ECOMHOUSE ©ALL RIGHTS RESERVED</a:t>
+            </a:r>
+          </a:p>
+        </p:txBody>
+      </p:sp>
+      <p:sp>
+        <p:nvSpPr>
+          <p:cNvPr id="6" name="TextBox 5"/>
+          <p:cNvSpPr txBox="1"/>
+          <p:nvPr/>
+        </p:nvSpPr>
+        <p:spPr>
+          <a:xfrm>
+            <a:off x="11475720" y="6565392"/>
+            <a:ext cx="548640" cy="228600"/>
+          </a:xfrm>
+          <a:prstGeom prst="rect">
+            <a:avLst/>
+          </a:prstGeom>
+          <a:noFill/>
+        </p:spPr>
+        <p:txBody>
+          <a:bodyPr wrap="square" lIns="0" rIns="0" tIns="0" bIns="0" anchor="t">
+            <a:spAutoFit/>
+          </a:bodyPr>
+          <a:lstStyle/>
+          <a:p>
+            <a:pPr algn="r"/>
+            <a:r>
+              <a:rPr sz="800" b="0" i="0">
+                <a:solidFill>
+                  <a:srgbClr val="EFEEEE"/>
+                </a:solidFill>
+                <a:latin typeface="Menlo"/>
+              </a:rPr>
+              <a:t>55</a:t>
+            </a:r>
+          </a:p>
+        </p:txBody>
+      </p:sp>
+      <p:sp>
+        <p:nvSpPr>
+          <p:cNvPr id="7" name="TextBox 6"/>
+          <p:cNvSpPr txBox="1"/>
+          <p:nvPr/>
+        </p:nvSpPr>
+        <p:spPr>
+          <a:xfrm>
+            <a:off x="640080" y="566928"/>
+            <a:ext cx="10911535" cy="228600"/>
+          </a:xfrm>
+          <a:prstGeom prst="rect">
+            <a:avLst/>
+          </a:prstGeom>
+          <a:noFill/>
+        </p:spPr>
+        <p:txBody>
+          <a:bodyPr wrap="square" lIns="0" rIns="0" tIns="0" bIns="0" anchor="t">
+            <a:spAutoFit/>
+          </a:bodyPr>
+          <a:lstStyle/>
+          <a:p>
+            <a:pPr algn="ctr"/>
+            <a:r>
+              <a:rPr sz="1000" b="1" i="0" spc="300">
+                <a:solidFill>
+                  <a:srgbClr val="F7D007"/>
+                </a:solidFill>
+                <a:latin typeface="Helvetica Neue"/>
+              </a:rPr>
+              <a:t>Samarbejde med EcomHouse · Honorar</a:t>
+            </a:r>
+          </a:p>
+        </p:txBody>
+      </p:sp>
+      <p:sp>
+        <p:nvSpPr>
+          <p:cNvPr id="8" name="TextBox 7"/>
+          <p:cNvSpPr txBox="1"/>
+          <p:nvPr/>
+        </p:nvSpPr>
+        <p:spPr>
+          <a:xfrm>
+            <a:off x="640080" y="841248"/>
+            <a:ext cx="10911535" cy="640080"/>
+          </a:xfrm>
+          <a:prstGeom prst="rect">
+            <a:avLst/>
+          </a:prstGeom>
+          <a:noFill/>
+        </p:spPr>
+        <p:txBody>
+          <a:bodyPr wrap="square" lIns="0" rIns="0" tIns="0" bIns="0" anchor="t">
+            <a:spAutoFit/>
+          </a:bodyPr>
+          <a:lstStyle/>
+          <a:p>
+            <a:pPr algn="ctr"/>
+            <a:r>
+              <a:rPr sz="3000" b="1" i="0" spc="-50">
+                <a:solidFill>
+                  <a:srgbClr val="FFFFFF"/>
+                </a:solidFill>
+                <a:latin typeface="Helvetica Neue"/>
+              </a:rPr>
+              <a:t>Vi vinder, når du vinder</a:t>
+            </a:r>
+          </a:p>
+        </p:txBody>
+      </p:sp>
+      <p:sp>
+        <p:nvSpPr>
+          <p:cNvPr id="9" name="TextBox 8"/>
+          <p:cNvSpPr txBox="1"/>
+          <p:nvPr/>
+        </p:nvSpPr>
+        <p:spPr>
+          <a:xfrm>
+            <a:off x="1828800" y="1463040"/>
+            <a:ext cx="8534095" cy="548640"/>
+          </a:xfrm>
+          <a:prstGeom prst="rect">
+            <a:avLst/>
+          </a:prstGeom>
+          <a:noFill/>
+        </p:spPr>
+        <p:txBody>
+          <a:bodyPr wrap="square" lIns="0" rIns="0" tIns="0" bIns="0" anchor="t">
+            <a:spAutoFit/>
+          </a:bodyPr>
+          <a:lstStyle/>
+          <a:p>
+            <a:pPr algn="ctr"/>
+            <a:r>
+              <a:rPr sz="1200" b="0" i="0">
+                <a:solidFill>
+                  <a:srgbClr val="999999"/>
+                </a:solidFill>
+                <a:latin typeface="Helvetica Neue"/>
+              </a:rPr>
+              <a:t>Et resultatbaseret honorar på hver vindende test, der rulles ud til 100% af trafikken. Engangsbetaling per test, intet attributionsvindue, ingen løbende hale.</a:t>
+            </a:r>
+          </a:p>
+        </p:txBody>
+      </p:sp>
+      <p:sp>
+        <p:nvSpPr>
+          <p:cNvPr id="10" name="Oval 9"/>
+          <p:cNvSpPr/>
+          <p:nvPr/>
+        </p:nvSpPr>
+        <p:spPr>
+          <a:xfrm>
+            <a:off x="777240" y="2112264"/>
+            <a:ext cx="100584" cy="100584"/>
+          </a:xfrm>
+          <a:prstGeom prst="ellipse">
+            <a:avLst/>
+          </a:prstGeom>
+          <a:solidFill>
+            <a:srgbClr val="22C55E"/>
+          </a:solidFill>
+          <a:ln>
+            <a:noFill/>
+          </a:ln>
+        </p:spPr>
+        <p:style>
+          <a:lnRef idx="1">
+            <a:schemeClr val="accent1"/>
+          </a:lnRef>
+          <a:fillRef idx="3">
+            <a:schemeClr val="accent1"/>
+          </a:fillRef>
+          <a:effectRef idx="2">
+            <a:schemeClr val="accent1"/>
+          </a:effectRef>
+          <a:fontRef idx="minor">
+            <a:schemeClr val="lt1"/>
+          </a:fontRef>
+        </p:style>
+        <p:txBody>
+          <a:bodyPr rtlCol="0" anchor="ctr"/>
+          <a:lstStyle/>
+          <a:p>
+            <a:pPr algn="ctr"/>
+          </a:p>
+        </p:txBody>
+      </p:sp>
+      <p:sp>
+        <p:nvSpPr>
+          <p:cNvPr id="11" name="TextBox 10"/>
+          <p:cNvSpPr txBox="1"/>
+          <p:nvPr/>
+        </p:nvSpPr>
+        <p:spPr>
+          <a:xfrm>
+            <a:off x="1051560" y="2066544"/>
+            <a:ext cx="10332720" cy="822960"/>
+          </a:xfrm>
+          <a:prstGeom prst="rect">
+            <a:avLst/>
+          </a:prstGeom>
+          <a:noFill/>
+        </p:spPr>
+        <p:txBody>
+          <a:bodyPr wrap="square" lIns="0" rIns="0" tIns="0" bIns="0" anchor="t">
+            <a:spAutoFit/>
+          </a:bodyPr>
+          <a:lstStyle/>
+          <a:p>
+            <a:pPr algn="l">
+              <a:lnSpc>
+                <a:spcPct val="105000"/>
+              </a:lnSpc>
+            </a:pPr>
+            <a:r>
+              <a:rPr sz="1050" b="1" i="0">
+                <a:solidFill>
+                  <a:srgbClr val="FFFFFF"/>
+                </a:solidFill>
+                <a:latin typeface="Helvetica Neue"/>
+              </a:rPr>
+              <a:t>Beregnet ud fra dine egne data. </a:t>
+            </a:r>
+            <a:r>
+              <a:rPr sz="1050" b="0" i="0">
+                <a:solidFill>
+                  <a:srgbClr val="CCCCCC"/>
+                </a:solidFill>
+                <a:latin typeface="Helvetica Neue"/>
+              </a:rPr>
+              <a:t>Honoraret er en procentdel af testens estimerede månedlige omsætningsløft, med den aftalte stadiemultiplikator fra Schedule A anvendt på tests i den øvre del af tragten, hvor løftet er projekteret frem for direkte målt.</a:t>
+            </a:r>
+          </a:p>
+        </p:txBody>
+      </p:sp>
+      <p:sp>
+        <p:nvSpPr>
+          <p:cNvPr id="12" name="Oval 11"/>
+          <p:cNvSpPr/>
+          <p:nvPr/>
+        </p:nvSpPr>
+        <p:spPr>
+          <a:xfrm>
+            <a:off x="777240" y="2551176"/>
+            <a:ext cx="100584" cy="100584"/>
+          </a:xfrm>
+          <a:prstGeom prst="ellipse">
+            <a:avLst/>
+          </a:prstGeom>
+          <a:solidFill>
+            <a:srgbClr val="22C55E"/>
+          </a:solidFill>
+          <a:ln>
+            <a:noFill/>
+          </a:ln>
+        </p:spPr>
+        <p:style>
+          <a:lnRef idx="1">
+            <a:schemeClr val="accent1"/>
+          </a:lnRef>
+          <a:fillRef idx="3">
+            <a:schemeClr val="accent1"/>
+          </a:fillRef>
+          <a:effectRef idx="2">
+            <a:schemeClr val="accent1"/>
+          </a:effectRef>
+          <a:fontRef idx="minor">
+            <a:schemeClr val="lt1"/>
+          </a:fontRef>
+        </p:style>
+        <p:txBody>
+          <a:bodyPr rtlCol="0" anchor="ctr"/>
+          <a:lstStyle/>
+          <a:p>
+            <a:pPr algn="ctr"/>
+          </a:p>
+        </p:txBody>
+      </p:sp>
+      <p:sp>
+        <p:nvSpPr>
+          <p:cNvPr id="13" name="TextBox 12"/>
+          <p:cNvSpPr txBox="1"/>
+          <p:nvPr/>
+        </p:nvSpPr>
+        <p:spPr>
+          <a:xfrm>
+            <a:off x="1051560" y="2505456"/>
+            <a:ext cx="10332720" cy="822960"/>
+          </a:xfrm>
+          <a:prstGeom prst="rect">
+            <a:avLst/>
+          </a:prstGeom>
+          <a:noFill/>
+        </p:spPr>
+        <p:txBody>
+          <a:bodyPr wrap="square" lIns="0" rIns="0" tIns="0" bIns="0" anchor="t">
+            <a:spAutoFit/>
+          </a:bodyPr>
+          <a:lstStyle/>
+          <a:p>
+            <a:pPr algn="l">
+              <a:lnSpc>
+                <a:spcPct val="105000"/>
+              </a:lnSpc>
+            </a:pPr>
+            <a:r>
+              <a:rPr sz="1050" b="1" i="0">
+                <a:solidFill>
+                  <a:srgbClr val="FFFFFF"/>
+                </a:solidFill>
+                <a:latin typeface="Helvetica Neue"/>
+              </a:rPr>
+              <a:t>Ingen løbende hale, intet attributionsvindue. </a:t>
+            </a:r>
+            <a:r>
+              <a:rPr sz="1050" b="0" i="0">
+                <a:solidFill>
+                  <a:srgbClr val="CCCCCC"/>
+                </a:solidFill>
+                <a:latin typeface="Helvetica Neue"/>
+              </a:rPr>
+              <a:t>Én faktura per vindende test ved udrulning, i SEK, aldrig en månedlig procentdel af omsætningen.</a:t>
+            </a:r>
+          </a:p>
+        </p:txBody>
+      </p:sp>
+      <p:sp>
+        <p:nvSpPr>
+          <p:cNvPr id="14" name="Oval 13"/>
+          <p:cNvSpPr/>
+          <p:nvPr/>
+        </p:nvSpPr>
+        <p:spPr>
+          <a:xfrm>
+            <a:off x="777240" y="2990088"/>
+            <a:ext cx="100584" cy="100584"/>
+          </a:xfrm>
+          <a:prstGeom prst="ellipse">
+            <a:avLst/>
+          </a:prstGeom>
+          <a:solidFill>
+            <a:srgbClr val="22C55E"/>
+          </a:solidFill>
+          <a:ln>
+            <a:noFill/>
+          </a:ln>
+        </p:spPr>
+        <p:style>
+          <a:lnRef idx="1">
+            <a:schemeClr val="accent1"/>
+          </a:lnRef>
+          <a:fillRef idx="3">
+            <a:schemeClr val="accent1"/>
+          </a:fillRef>
+          <a:effectRef idx="2">
+            <a:schemeClr val="accent1"/>
+          </a:effectRef>
+          <a:fontRef idx="minor">
+            <a:schemeClr val="lt1"/>
+          </a:fontRef>
+        </p:style>
+        <p:txBody>
+          <a:bodyPr rtlCol="0" anchor="ctr"/>
+          <a:lstStyle/>
+          <a:p>
+            <a:pPr algn="ctr"/>
+          </a:p>
+        </p:txBody>
+      </p:sp>
+      <p:sp>
+        <p:nvSpPr>
+          <p:cNvPr id="15" name="TextBox 14"/>
+          <p:cNvSpPr txBox="1"/>
+          <p:nvPr/>
+        </p:nvSpPr>
+        <p:spPr>
+          <a:xfrm>
+            <a:off x="1051560" y="2944368"/>
+            <a:ext cx="10332720" cy="822960"/>
+          </a:xfrm>
+          <a:prstGeom prst="rect">
+            <a:avLst/>
+          </a:prstGeom>
+          <a:noFill/>
+        </p:spPr>
+        <p:txBody>
+          <a:bodyPr wrap="square" lIns="0" rIns="0" tIns="0" bIns="0" anchor="t">
+            <a:spAutoFit/>
+          </a:bodyPr>
+          <a:lstStyle/>
+          <a:p>
+            <a:pPr algn="l">
+              <a:lnSpc>
+                <a:spcPct val="105000"/>
+              </a:lnSpc>
+            </a:pPr>
+            <a:r>
+              <a:rPr sz="1050" b="1" i="0">
+                <a:solidFill>
+                  <a:srgbClr val="FFFFFF"/>
+                </a:solidFill>
+                <a:latin typeface="Helvetica Neue"/>
+              </a:rPr>
+              <a:t>Valgfrit fast månedligt retainer </a:t>
+            </a:r>
+            <a:r>
+              <a:rPr sz="1050" b="0" i="0">
+                <a:solidFill>
+                  <a:srgbClr val="CCCCCC"/>
+                </a:solidFill>
+                <a:latin typeface="Helvetica Neue"/>
+              </a:rPr>
+              <a:t>i SEK, hvis du foretrækker et forudsigeligt budget. Det kan lægges oven i resultathonoraret eller erstatte det, og det er ugyldigt, medmindre det aftales.</a:t>
+            </a:r>
+          </a:p>
+        </p:txBody>
+      </p:sp>
+    </p:spTree>
+  </p:cSld>
+  <p:clrMapOvr>
+    <a:masterClrMapping/>
+  </p:clrMapOvr>
+</p:sld>
+</file>
+
+<file path=ppt/slides/slide57.xml><?xml version="1.0" encoding="utf-8"?>
+<p:sld xmlns:a="http://schemas.openxmlformats.org/drawingml/2006/main" xmlns:p="http://schemas.openxmlformats.org/presentationml/2006/main" xmlns:r="http://schemas.openxmlformats.org/officeDocument/2006/relationships">
+  <p:cSld>
+    <p:spTree>
+      <p:nvGrpSpPr>
+        <p:cNvPr id="1" name=""/>
+        <p:cNvGrpSpPr/>
+        <p:nvPr/>
+      </p:nvGrpSpPr>
+      <p:grpSpPr/>
+      <p:sp>
+        <p:nvSpPr>
+          <p:cNvPr id="2" name="Rectangle 1"/>
+          <p:cNvSpPr/>
+          <p:nvPr/>
+        </p:nvSpPr>
+        <p:spPr>
+          <a:xfrm>
+            <a:off x="0" y="0"/>
+            <a:ext cx="12191695" cy="6858000"/>
+          </a:xfrm>
+          <a:prstGeom prst="rect">
+            <a:avLst/>
+          </a:prstGeom>
+          <a:solidFill>
+            <a:srgbClr val="000000"/>
+          </a:solidFill>
+          <a:ln>
+            <a:noFill/>
+          </a:ln>
+        </p:spPr>
+        <p:style>
+          <a:lnRef idx="1">
+            <a:schemeClr val="accent1"/>
+          </a:lnRef>
+          <a:fillRef idx="3">
+            <a:schemeClr val="accent1"/>
+          </a:fillRef>
+          <a:effectRef idx="2">
+            <a:schemeClr val="accent1"/>
+          </a:effectRef>
+          <a:fontRef idx="minor">
+            <a:schemeClr val="lt1"/>
+          </a:fontRef>
+        </p:style>
+        <p:txBody>
+          <a:bodyPr rtlCol="0" anchor="ctr"/>
+          <a:lstStyle/>
+          <a:p>
+            <a:pPr algn="ctr"/>
+          </a:p>
+        </p:txBody>
+      </p:sp>
+      <p:pic>
+        <p:nvPicPr>
+          <p:cNvPr id="3" name="Picture 2" descr="ecomhouse-wordmark.png"/>
+          <p:cNvPicPr>
+            <a:picLocks noChangeAspect="1"/>
+          </p:cNvPicPr>
+          <p:nvPr/>
+        </p:nvPicPr>
+        <p:blipFill>
+          <a:blip r:embed="rId2"/>
+          <a:stretch>
+            <a:fillRect/>
+          </a:stretch>
+        </p:blipFill>
+        <p:spPr>
+          <a:xfrm>
+            <a:off x="292608" y="201168"/>
+            <a:ext cx="1873736" cy="201168"/>
+          </a:xfrm>
+          <a:prstGeom prst="rect">
+            <a:avLst/>
+          </a:prstGeom>
+        </p:spPr>
+      </p:pic>
+      <p:sp>
+        <p:nvSpPr>
+          <p:cNvPr id="4" name="TextBox 3"/>
+          <p:cNvSpPr txBox="1"/>
+          <p:nvPr/>
+        </p:nvSpPr>
+        <p:spPr>
+          <a:xfrm>
+            <a:off x="11475720" y="201168"/>
+            <a:ext cx="548640" cy="274320"/>
+          </a:xfrm>
+          <a:prstGeom prst="rect">
+            <a:avLst/>
+          </a:prstGeom>
+          <a:noFill/>
+        </p:spPr>
+        <p:txBody>
+          <a:bodyPr wrap="square" lIns="0" rIns="0" tIns="0" bIns="0" anchor="t">
+            <a:spAutoFit/>
+          </a:bodyPr>
+          <a:lstStyle/>
+          <a:p>
+            <a:pPr algn="r"/>
+            <a:r>
+              <a:rPr sz="1000" b="0" i="0">
+                <a:solidFill>
+                  <a:srgbClr val="EFEEEE"/>
+                </a:solidFill>
+                <a:latin typeface="Helvetica Neue"/>
+              </a:rPr>
+              <a:t>2026</a:t>
+            </a:r>
+          </a:p>
+        </p:txBody>
+      </p:sp>
+      <p:sp>
+        <p:nvSpPr>
+          <p:cNvPr id="5" name="TextBox 4"/>
+          <p:cNvSpPr txBox="1"/>
+          <p:nvPr/>
+        </p:nvSpPr>
+        <p:spPr>
+          <a:xfrm>
+            <a:off x="292608" y="6565392"/>
+            <a:ext cx="4114800" cy="228600"/>
+          </a:xfrm>
+          <a:prstGeom prst="rect">
+            <a:avLst/>
+          </a:prstGeom>
+          <a:noFill/>
+        </p:spPr>
+        <p:txBody>
+          <a:bodyPr wrap="square" lIns="0" rIns="0" tIns="0" bIns="0" anchor="t">
+            <a:spAutoFit/>
+          </a:bodyPr>
+          <a:lstStyle/>
+          <a:p>
+            <a:pPr algn="l"/>
+            <a:r>
+              <a:rPr sz="800" b="0" i="0" spc="150">
+                <a:solidFill>
+                  <a:srgbClr val="EFEEEE"/>
+                </a:solidFill>
+                <a:latin typeface="Helvetica Neue"/>
+              </a:rPr>
+              <a:t>ECOMHOUSE ©ALL RIGHTS RESERVED</a:t>
+            </a:r>
+          </a:p>
+        </p:txBody>
+      </p:sp>
+      <p:sp>
+        <p:nvSpPr>
+          <p:cNvPr id="6" name="TextBox 5"/>
+          <p:cNvSpPr txBox="1"/>
+          <p:nvPr/>
+        </p:nvSpPr>
+        <p:spPr>
+          <a:xfrm>
+            <a:off x="11475720" y="6565392"/>
+            <a:ext cx="548640" cy="228600"/>
+          </a:xfrm>
+          <a:prstGeom prst="rect">
+            <a:avLst/>
+          </a:prstGeom>
+          <a:noFill/>
+        </p:spPr>
+        <p:txBody>
+          <a:bodyPr wrap="square" lIns="0" rIns="0" tIns="0" bIns="0" anchor="t">
+            <a:spAutoFit/>
+          </a:bodyPr>
+          <a:lstStyle/>
+          <a:p>
+            <a:pPr algn="r"/>
+            <a:r>
+              <a:rPr sz="800" b="0" i="0">
+                <a:solidFill>
+                  <a:srgbClr val="EFEEEE"/>
+                </a:solidFill>
+                <a:latin typeface="Menlo"/>
+              </a:rPr>
+              <a:t>56</a:t>
+            </a:r>
+          </a:p>
+        </p:txBody>
+      </p:sp>
+      <p:sp>
+        <p:nvSpPr>
           <p:cNvPr id="7" name="Oval 6"/>
           <p:cNvSpPr/>
           <p:nvPr/>

</xml_diff>